<commit_message>
docs: rebuild deck as a strict fill of the Code Flayer 2.0 template
Keep every template shape at its original position, size, colour and font
size and replace only placeholder text. Drops the earlier layout changes,
added arrows and theme link-colour edit; the QR code the closing slide asks
for is the only added object.

Co-Authored-By: Claude Opus 5.5 <noreply@anthropic.com>
Claude-Session: https://claude.ai/code/session_01FwuQgG7UNrQVjMVMPvyfY9
</commit_message>
<xml_diff>
--- a/presentation/CLINISCOPE_PS11R3_Hackathon_Presentation.pptx
+++ b/presentation/CLINISCOPE_PS11R3_Hackathon_Presentation.pptx
@@ -3296,7 +3296,7 @@
         <p:spPr>
           <a:xfrm>
             <a:off x="731520" y="566928"/>
-            <a:ext cx="7589520" cy="274320"/>
+            <a:ext cx="4114800" cy="274320"/>
           </a:xfrm>
           <a:prstGeom prst="rect">
             <a:avLst/>
@@ -3317,7 +3317,7 @@
                 </a:solidFill>
                 <a:latin typeface="Aptos"/>
               </a:rPr>
-              <a:t>CODE FLAYER 2.0  •  PROJECT PRESENTATION  •  PS-11R3</a:t>
+              <a:t>CODE FLAYER 2.0  •  PROJECT PRESENTATION</a:t>
             </a:r>
           </a:p>
         </p:txBody>
@@ -3330,8 +3330,8 @@
         </p:nvSpPr>
         <p:spPr>
           <a:xfrm>
-            <a:off x="731520" y="1325880"/>
-            <a:ext cx="7772400" cy="1325880"/>
+            <a:off x="731520" y="1508760"/>
+            <a:ext cx="7498079" cy="1143000"/>
           </a:xfrm>
           <a:prstGeom prst="rect">
             <a:avLst/>
@@ -3346,25 +3346,13 @@
           <a:p>
             <a:pPr algn="l"/>
             <a:r>
-              <a:rPr sz="4800" b="1">
+              <a:rPr sz="3400" b="1">
                 <a:solidFill>
                   <a:srgbClr val="FFFFFF"/>
                 </a:solidFill>
                 <a:latin typeface="Aptos"/>
               </a:rPr>
               <a:t>CLINISCOPE</a:t>
-            </a:r>
-          </a:p>
-          <a:p>
-            <a:pPr algn="l"/>
-            <a:r>
-              <a:rPr sz="2200" b="1">
-                <a:solidFill>
-                  <a:srgbClr val="C0CAFF"/>
-                </a:solidFill>
-                <a:latin typeface="Aptos"/>
-              </a:rPr>
-              <a:t>Healthcare Record Contradiction Detector</a:t>
             </a:r>
           </a:p>
         </p:txBody>
@@ -3377,8 +3365,8 @@
         </p:nvSpPr>
         <p:spPr>
           <a:xfrm>
-            <a:off x="768096" y="2788920"/>
-            <a:ext cx="7772400" cy="457200"/>
+            <a:off x="768096" y="2697480"/>
+            <a:ext cx="7132320" cy="548640"/>
           </a:xfrm>
           <a:prstGeom prst="rect">
             <a:avLst/>
@@ -3393,7 +3381,19 @@
           <a:p>
             <a:pPr algn="l"/>
             <a:r>
-              <a:rPr sz="1800" b="0" i="1">
+              <a:rPr sz="1800" b="0">
+                <a:solidFill>
+                  <a:srgbClr val="D0D7E7"/>
+                </a:solidFill>
+                <a:latin typeface="Aptos"/>
+              </a:rPr>
+              <a:t>Healthcare Record Contradiction Detector</a:t>
+            </a:r>
+          </a:p>
+          <a:p>
+            <a:pPr algn="l"/>
+            <a:r>
+              <a:rPr sz="1800" b="0">
                 <a:solidFill>
                   <a:srgbClr val="D0D7E7"/>
                 </a:solidFill>
@@ -3412,7 +3412,7 @@
         </p:nvSpPr>
         <p:spPr>
           <a:xfrm>
-            <a:off x="777240" y="3429000"/>
+            <a:off x="777240" y="3520440"/>
             <a:ext cx="1051560" cy="64008"/>
           </a:xfrm>
           <a:prstGeom prst="rect">
@@ -3457,7 +3457,7 @@
         </p:nvSpPr>
         <p:spPr>
           <a:xfrm>
-            <a:off x="777240" y="3794760"/>
+            <a:off x="777240" y="3886200"/>
             <a:ext cx="6949440" cy="347472"/>
           </a:xfrm>
           <a:prstGeom prst="rect">
@@ -3479,16 +3479,7 @@
                 </a:solidFill>
                 <a:latin typeface="Aptos"/>
               </a:rPr>
-              <a:t>TEAM  </a:t>
-            </a:r>
-            <a:r>
-              <a:rPr sz="1600" b="0">
-                <a:solidFill>
-                  <a:srgbClr val="A0AECC"/>
-                </a:solidFill>
-                <a:latin typeface="Aptos"/>
-              </a:rPr>
-              <a:t>[Add official team name]</a:t>
+              <a:t>TEAM  [Add official team name]</a:t>
             </a:r>
           </a:p>
         </p:txBody>
@@ -3501,7 +3492,7 @@
         </p:nvSpPr>
         <p:spPr>
           <a:xfrm>
-            <a:off x="777240" y="4297680"/>
+            <a:off x="777240" y="4389120"/>
             <a:ext cx="7132320" cy="777240"/>
           </a:xfrm>
           <a:prstGeom prst="rect">
@@ -3523,37 +3514,19 @@
                 </a:solidFill>
                 <a:latin typeface="Aptos"/>
               </a:rPr>
-              <a:t>Team leader: </a:t>
-            </a:r>
+              <a:t>Team leader: [Add team leader]</a:t>
+            </a:r>
+          </a:p>
+          <a:p>
+            <a:pPr algn="l"/>
             <a:r>
               <a:rPr sz="1300" b="0">
                 <a:solidFill>
-                  <a:srgbClr val="A0AECC"/>
-                </a:solidFill>
-                <a:latin typeface="Aptos"/>
-              </a:rPr>
-              <a:t>[Add team leader]</a:t>
-            </a:r>
-          </a:p>
-          <a:p>
-            <a:pPr algn="l"/>
-            <a:r>
-              <a:rPr sz="1300" b="0">
-                <a:solidFill>
                   <a:srgbClr val="D0D7E7"/>
                 </a:solidFill>
                 <a:latin typeface="Aptos"/>
               </a:rPr>
-              <a:t>Team members: </a:t>
-            </a:r>
-            <a:r>
-              <a:rPr sz="1300" b="0">
-                <a:solidFill>
-                  <a:srgbClr val="A0AECC"/>
-                </a:solidFill>
-                <a:latin typeface="Aptos"/>
-              </a:rPr>
-              <a:t>[Add member names]</a:t>
+              <a:t>Team members: [Add member names]</a:t>
             </a:r>
           </a:p>
         </p:txBody>
@@ -3567,7 +3540,7 @@
         <p:spPr>
           <a:xfrm>
             <a:off x="777240" y="6080760"/>
-            <a:ext cx="7680960" cy="228600"/>
+            <a:ext cx="6858000" cy="228600"/>
           </a:xfrm>
           <a:prstGeom prst="rect">
             <a:avLst/>
@@ -3588,7 +3561,7 @@
                 </a:solidFill>
                 <a:latin typeface="Aptos"/>
               </a:rPr>
-              <a:t>Domain: Healthcare  |  Problem statement PS-11R3  |  Vishnu Institute of Technology, Bhimavaram</a:t>
+              <a:t>Healthcare  •  PS-11R3     |     Vishnu Institute of Technology, Bhimavaram</a:t>
             </a:r>
           </a:p>
         </p:txBody>
@@ -3754,7 +3727,7 @@
                 </a:solidFill>
                 <a:latin typeface="Aptos"/>
               </a:rPr>
-              <a:t>PS-11R3 · Healthcare Record Contradiction Detector. The framing below is our own interpretation of the problem.</a:t>
+              <a:t>PS-11R3: Healthcare Record Contradiction Detector. The framing below is the team's interpretation.</a:t>
             </a:r>
           </a:p>
         </p:txBody>
@@ -3902,8 +3875,8 @@
         </p:nvSpPr>
         <p:spPr>
           <a:xfrm>
-            <a:off x="640080" y="1737360"/>
-            <a:ext cx="5349240" cy="1783080"/>
+            <a:off x="640080" y="1874519"/>
+            <a:ext cx="5349240" cy="1508760"/>
           </a:xfrm>
           <a:prstGeom prst="roundRect">
             <a:avLst>
@@ -3949,8 +3922,8 @@
         </p:nvSpPr>
         <p:spPr>
           <a:xfrm>
-            <a:off x="640080" y="1737360"/>
-            <a:ext cx="64008" cy="1783080"/>
+            <a:off x="640080" y="1874519"/>
+            <a:ext cx="64008" cy="1508760"/>
           </a:xfrm>
           <a:prstGeom prst="rect">
             <a:avLst/>
@@ -3994,7 +3967,7 @@
         </p:nvSpPr>
         <p:spPr>
           <a:xfrm>
-            <a:off x="859536" y="1901952"/>
+            <a:off x="859536" y="2057400"/>
             <a:ext cx="4937759" cy="320040"/>
           </a:xfrm>
           <a:prstGeom prst="rect">
@@ -4029,8 +4002,8 @@
         </p:nvSpPr>
         <p:spPr>
           <a:xfrm>
-            <a:off x="859536" y="2286000"/>
-            <a:ext cx="4937759" cy="1097280"/>
+            <a:off x="859536" y="2496312"/>
+            <a:ext cx="4937759" cy="758952"/>
           </a:xfrm>
           <a:prstGeom prst="rect">
             <a:avLst/>
@@ -4045,13 +4018,13 @@
           <a:p>
             <a:pPr algn="l"/>
             <a:r>
-              <a:rPr sz="1300" b="0">
+              <a:rPr sz="1400" b="0">
                 <a:solidFill>
                   <a:srgbClr val="394252"/>
                 </a:solidFill>
                 <a:latin typeface="Aptos"/>
               </a:rPr>
-              <a:t>Patient information is spread across discharge summaries, intake forms, medication lists and lab reports. Allergies, doses, diagnoses and lab values can differ between records, and finding those differences by hand is slow.</a:t>
+              <a:t>Patient information is spread across many documents. Allergies, doses, diagnoses and lab results can differ, and spotting that by hand is slow.</a:t>
             </a:r>
           </a:p>
         </p:txBody>
@@ -4064,8 +4037,8 @@
         </p:nvSpPr>
         <p:spPr>
           <a:xfrm>
-            <a:off x="6217920" y="1737360"/>
-            <a:ext cx="5303520" cy="1783080"/>
+            <a:off x="6217920" y="1874519"/>
+            <a:ext cx="5303520" cy="1508760"/>
           </a:xfrm>
           <a:prstGeom prst="roundRect">
             <a:avLst>
@@ -4111,8 +4084,8 @@
         </p:nvSpPr>
         <p:spPr>
           <a:xfrm>
-            <a:off x="6217920" y="1737360"/>
-            <a:ext cx="64008" cy="1783080"/>
+            <a:off x="6217920" y="1874519"/>
+            <a:ext cx="64008" cy="1508760"/>
           </a:xfrm>
           <a:prstGeom prst="rect">
             <a:avLst/>
@@ -4156,7 +4129,7 @@
         </p:nvSpPr>
         <p:spPr>
           <a:xfrm>
-            <a:off x="6437376" y="1901952"/>
+            <a:off x="6437376" y="2057400"/>
             <a:ext cx="4892040" cy="320040"/>
           </a:xfrm>
           <a:prstGeom prst="rect">
@@ -4178,16 +4151,7 @@
                 </a:solidFill>
                 <a:latin typeface="Aptos"/>
               </a:rPr>
-              <a:t>02  TARGET USERS </a:t>
-            </a:r>
-            <a:r>
-              <a:rPr sz="1200" b="0">
-                <a:solidFill>
-                  <a:srgbClr val="767F90"/>
-                </a:solidFill>
-                <a:latin typeface="Aptos"/>
-              </a:rPr>
-              <a:t>(INTENDED)</a:t>
+              <a:t>02  TARGET USERS</a:t>
             </a:r>
           </a:p>
         </p:txBody>
@@ -4200,8 +4164,8 @@
         </p:nvSpPr>
         <p:spPr>
           <a:xfrm>
-            <a:off x="6437376" y="2286000"/>
-            <a:ext cx="4892040" cy="1097280"/>
+            <a:off x="6437376" y="2496312"/>
+            <a:ext cx="4892040" cy="758952"/>
           </a:xfrm>
           <a:prstGeom prst="rect">
             <a:avLst/>
@@ -4214,123 +4178,15 @@
           </a:bodyPr>
           <a:lstStyle/>
           <a:p>
-            <a:pPr algn="l" marL="228600" indent="-228600">
-              <a:spcAft>
-                <a:spcPts val="200"/>
-              </a:spcAft>
-              <a:buClr>
-                <a:srgbClr val="2DA6A0"/>
-              </a:buClr>
-              <a:buFont typeface="Arial"/>
-              <a:buChar char="•"/>
-            </a:pPr>
-            <a:r>
-              <a:rPr sz="1300" b="1">
-                <a:solidFill>
-                  <a:srgbClr val="162239"/>
-                </a:solidFill>
-                <a:latin typeface="Aptos"/>
-              </a:rPr>
-              <a:t>Clinicians</a:t>
-            </a:r>
-            <a:r>
-              <a:rPr sz="1300" b="0">
+            <a:pPr algn="l"/>
+            <a:r>
+              <a:rPr sz="1400" b="0">
                 <a:solidFill>
                   <a:srgbClr val="394252"/>
                 </a:solidFill>
                 <a:latin typeface="Aptos"/>
               </a:rPr>
-              <a:t> reviewing patient records</a:t>
-            </a:r>
-          </a:p>
-          <a:p>
-            <a:pPr algn="l" marL="228600" indent="-228600">
-              <a:spcAft>
-                <a:spcPts val="200"/>
-              </a:spcAft>
-              <a:buClr>
-                <a:srgbClr val="2DA6A0"/>
-              </a:buClr>
-              <a:buFont typeface="Arial"/>
-              <a:buChar char="•"/>
-            </a:pPr>
-            <a:r>
-              <a:rPr sz="1300" b="1">
-                <a:solidFill>
-                  <a:srgbClr val="162239"/>
-                </a:solidFill>
-                <a:latin typeface="Aptos"/>
-              </a:rPr>
-              <a:t>Medical-records / HIM teams</a:t>
-            </a:r>
-            <a:r>
-              <a:rPr sz="1300" b="0">
-                <a:solidFill>
-                  <a:srgbClr val="394252"/>
-                </a:solidFill>
-                <a:latin typeface="Aptos"/>
-              </a:rPr>
-              <a:t/>
-            </a:r>
-          </a:p>
-          <a:p>
-            <a:pPr algn="l" marL="228600" indent="-228600">
-              <a:spcAft>
-                <a:spcPts val="200"/>
-              </a:spcAft>
-              <a:buClr>
-                <a:srgbClr val="2DA6A0"/>
-              </a:buClr>
-              <a:buFont typeface="Arial"/>
-              <a:buChar char="•"/>
-            </a:pPr>
-            <a:r>
-              <a:rPr sz="1300" b="1">
-                <a:solidFill>
-                  <a:srgbClr val="162239"/>
-                </a:solidFill>
-                <a:latin typeface="Aptos"/>
-              </a:rPr>
-              <a:t>Clinical quality &amp; patient-safety</a:t>
-            </a:r>
-            <a:r>
-              <a:rPr sz="1300" b="0">
-                <a:solidFill>
-                  <a:srgbClr val="394252"/>
-                </a:solidFill>
-                <a:latin typeface="Aptos"/>
-              </a:rPr>
-              <a:t> reviewers</a:t>
-            </a:r>
-          </a:p>
-          <a:p>
-            <a:pPr algn="l" marL="228600" indent="-228600">
-              <a:spcAft>
-                <a:spcPts val="200"/>
-              </a:spcAft>
-              <a:buClr>
-                <a:srgbClr val="2DA6A0"/>
-              </a:buClr>
-              <a:buFont typeface="Arial"/>
-              <a:buChar char="•"/>
-            </a:pPr>
-            <a:r>
-              <a:rPr sz="1300" b="1">
-                <a:solidFill>
-                  <a:srgbClr val="162239"/>
-                </a:solidFill>
-                <a:latin typeface="Aptos"/>
-              </a:rPr>
-              <a:t>Authorized staff</a:t>
-            </a:r>
-            <a:r>
-              <a:rPr sz="1300" b="0">
-                <a:solidFill>
-                  <a:srgbClr val="394252"/>
-                </a:solidFill>
-                <a:latin typeface="Aptos"/>
-              </a:rPr>
-              <a:t> reconciling records</a:t>
+              <a:t>Intended users: clinicians reviewing records, medical-records (HIM) teams, clinical quality and patient-safety reviewers, and authorized staff reconciling records.</a:t>
             </a:r>
           </a:p>
         </p:txBody>
@@ -4343,8 +4199,8 @@
         </p:nvSpPr>
         <p:spPr>
           <a:xfrm>
-            <a:off x="640080" y="3657600"/>
-            <a:ext cx="5349240" cy="1783080"/>
+            <a:off x="640080" y="3611880"/>
+            <a:ext cx="5349240" cy="1508760"/>
           </a:xfrm>
           <a:prstGeom prst="roundRect">
             <a:avLst>
@@ -4390,8 +4246,8 @@
         </p:nvSpPr>
         <p:spPr>
           <a:xfrm>
-            <a:off x="640080" y="3657600"/>
-            <a:ext cx="64008" cy="1783080"/>
+            <a:off x="640080" y="3611880"/>
+            <a:ext cx="64008" cy="1508760"/>
           </a:xfrm>
           <a:prstGeom prst="rect">
             <a:avLst/>
@@ -4435,7 +4291,7 @@
         </p:nvSpPr>
         <p:spPr>
           <a:xfrm>
-            <a:off x="859536" y="3822191"/>
+            <a:off x="859536" y="3794760"/>
             <a:ext cx="4937759" cy="320040"/>
           </a:xfrm>
           <a:prstGeom prst="rect">
@@ -4470,8 +4326,8 @@
         </p:nvSpPr>
         <p:spPr>
           <a:xfrm>
-            <a:off x="859536" y="4206240"/>
-            <a:ext cx="4937759" cy="1097280"/>
+            <a:off x="859536" y="4233672"/>
+            <a:ext cx="4937759" cy="758952"/>
           </a:xfrm>
           <a:prstGeom prst="rect">
             <a:avLst/>
@@ -4484,93 +4340,39 @@
           </a:bodyPr>
           <a:lstStyle/>
           <a:p>
-            <a:pPr algn="l" marL="228600" indent="-228600">
-              <a:spcAft>
-                <a:spcPts val="200"/>
-              </a:spcAft>
-              <a:buClr>
-                <a:srgbClr val="2DA6A0"/>
-              </a:buClr>
-              <a:buFont typeface="Arial"/>
-              <a:buChar char="•"/>
-            </a:pPr>
-            <a:r>
-              <a:rPr sz="1300" b="1">
-                <a:solidFill>
-                  <a:srgbClr val="162239"/>
-                </a:solidFill>
-                <a:latin typeface="Aptos"/>
-              </a:rPr>
-              <a:t>Fragmented: </a:t>
-            </a:r>
-            <a:r>
-              <a:rPr sz="1300" b="0">
+            <a:pPr algn="l"/>
+            <a:r>
+              <a:rPr sz="1400" b="0">
                 <a:solidFill>
                   <a:srgbClr val="394252"/>
                 </a:solidFill>
                 <a:latin typeface="Aptos"/>
               </a:rPr>
-              <a:t>related statements sit in separate documents</a:t>
-            </a:r>
-          </a:p>
-          <a:p>
-            <a:pPr algn="l" marL="228600" indent="-228600">
-              <a:spcAft>
-                <a:spcPts val="200"/>
-              </a:spcAft>
-              <a:buClr>
-                <a:srgbClr val="2DA6A0"/>
-              </a:buClr>
-              <a:buFont typeface="Arial"/>
-              <a:buChar char="•"/>
-            </a:pPr>
-            <a:r>
-              <a:rPr sz="1300" b="1">
-                <a:solidFill>
-                  <a:srgbClr val="162239"/>
-                </a:solidFill>
-                <a:latin typeface="Aptos"/>
-              </a:rPr>
-              <a:t>Context-sensitive: </a:t>
-            </a:r>
-            <a:r>
-              <a:rPr sz="1300" b="0">
+              <a:t>• Fragmented: statements sit in separate files</a:t>
+            </a:r>
+          </a:p>
+          <a:p>
+            <a:pPr algn="l"/>
+            <a:r>
+              <a:rPr sz="1400" b="0">
                 <a:solidFill>
                   <a:srgbClr val="394252"/>
                 </a:solidFill>
                 <a:latin typeface="Aptos"/>
               </a:rPr>
-              <a:t>dates, negation and dose changes blur conflicts</a:t>
-            </a:r>
-          </a:p>
-          <a:p>
-            <a:pPr algn="l" marL="228600" indent="-228600">
-              <a:spcAft>
-                <a:spcPts val="200"/>
-              </a:spcAft>
-              <a:buClr>
-                <a:srgbClr val="2DA6A0"/>
-              </a:buClr>
-              <a:buFont typeface="Arial"/>
-              <a:buChar char="•"/>
-            </a:pPr>
-            <a:r>
-              <a:rPr sz="1300" b="1">
-                <a:solidFill>
-                  <a:srgbClr val="162239"/>
-                </a:solidFill>
-                <a:latin typeface="Aptos"/>
-              </a:rPr>
-              <a:t>Hard to trace: </a:t>
-            </a:r>
-            <a:r>
-              <a:rPr sz="1300" b="0">
+              <a:t>• Context: dates, negation, dose changes</a:t>
+            </a:r>
+          </a:p>
+          <a:p>
+            <a:pPr algn="l"/>
+            <a:r>
+              <a:rPr sz="1400" b="0">
                 <a:solidFill>
                   <a:srgbClr val="394252"/>
                 </a:solidFill>
                 <a:latin typeface="Aptos"/>
               </a:rPr>
-              <a:t>each discrepancy needs its original source</a:t>
+              <a:t>• Traceability: each conflict needs its source</a:t>
             </a:r>
           </a:p>
         </p:txBody>
@@ -4583,8 +4385,8 @@
         </p:nvSpPr>
         <p:spPr>
           <a:xfrm>
-            <a:off x="6217920" y="3657600"/>
-            <a:ext cx="5303520" cy="1783080"/>
+            <a:off x="6217920" y="3611880"/>
+            <a:ext cx="5303520" cy="1508760"/>
           </a:xfrm>
           <a:prstGeom prst="roundRect">
             <a:avLst>
@@ -4630,8 +4432,8 @@
         </p:nvSpPr>
         <p:spPr>
           <a:xfrm>
-            <a:off x="6217920" y="3657600"/>
-            <a:ext cx="64008" cy="1783080"/>
+            <a:off x="6217920" y="3611880"/>
+            <a:ext cx="64008" cy="1508760"/>
           </a:xfrm>
           <a:prstGeom prst="rect">
             <a:avLst/>
@@ -4675,7 +4477,7 @@
         </p:nvSpPr>
         <p:spPr>
           <a:xfrm>
-            <a:off x="6437376" y="3822191"/>
+            <a:off x="6437376" y="3794760"/>
             <a:ext cx="4892040" cy="320040"/>
           </a:xfrm>
           <a:prstGeom prst="rect">
@@ -4710,8 +4512,8 @@
         </p:nvSpPr>
         <p:spPr>
           <a:xfrm>
-            <a:off x="6437376" y="4206240"/>
-            <a:ext cx="4892040" cy="1097280"/>
+            <a:off x="6437376" y="4233672"/>
+            <a:ext cx="4892040" cy="758952"/>
           </a:xfrm>
           <a:prstGeom prst="rect">
             <a:avLst/>
@@ -4726,13 +4528,13 @@
           <a:p>
             <a:pPr algn="l"/>
             <a:r>
-              <a:rPr sz="1300" b="0">
+              <a:rPr sz="1400" b="0">
                 <a:solidFill>
                   <a:srgbClr val="394252"/>
                 </a:solidFill>
                 <a:latin typeface="Aptos"/>
               </a:rPr>
-              <a:t>A warning alone is not enough. Reviewers need the original evidence, the context (dates, history) to judge it, and a controlled way to record their final decision.</a:t>
+              <a:t>A warning is not enough. Reviewers need the original evidence, its context (dates, history) and a controlled way to record their decision.</a:t>
             </a:r>
           </a:p>
         </p:txBody>
@@ -4745,8 +4547,8 @@
         </p:nvSpPr>
         <p:spPr>
           <a:xfrm>
-            <a:off x="777240" y="5623560"/>
-            <a:ext cx="10698480" cy="594360"/>
+            <a:off x="777240" y="5577840"/>
+            <a:ext cx="10698480" cy="411480"/>
           </a:xfrm>
           <a:prstGeom prst="rect">
             <a:avLst/>
@@ -4761,22 +4563,13 @@
           <a:p>
             <a:pPr algn="l"/>
             <a:r>
-              <a:rPr sz="1400" b="1">
-                <a:solidFill>
-                  <a:srgbClr val="5369DC"/>
-                </a:solidFill>
-                <a:latin typeface="Aptos"/>
-              </a:rPr>
-              <a:t>ONE-LINE PROBLEM:  </a:t>
-            </a:r>
-            <a:r>
-              <a:rPr sz="1400" b="0">
+              <a:rPr sz="1500" b="1">
                 <a:solidFill>
                   <a:srgbClr val="162239"/>
                 </a:solidFill>
                 <a:latin typeface="Aptos"/>
               </a:rPr>
-              <a:t>How might we help healthcare reviewers identify and investigate inconsistencies across medical documents, with clear source evidence and human oversight?</a:t>
+              <a:t>ONE-LINE PROBLEM:  How can reviewers find and investigate conflicts across medical records with clear source evidence and human oversight?</a:t>
             </a:r>
           </a:p>
         </p:txBody>
@@ -4824,8 +4617,8 @@
         </p:nvSpPr>
         <p:spPr>
           <a:xfrm>
-            <a:off x="10744200" y="6473952"/>
-            <a:ext cx="822960" cy="201168"/>
+            <a:off x="11064240" y="6473952"/>
+            <a:ext cx="502920" cy="201168"/>
           </a:xfrm>
           <a:prstGeom prst="rect">
             <a:avLst/>
@@ -5125,8 +4918,8 @@
         </p:nvSpPr>
         <p:spPr>
           <a:xfrm>
-            <a:off x="640080" y="1737360"/>
-            <a:ext cx="6629400" cy="2057400"/>
+            <a:off x="640080" y="1874519"/>
+            <a:ext cx="6629400" cy="1874519"/>
           </a:xfrm>
           <a:prstGeom prst="roundRect">
             <a:avLst>
@@ -5172,8 +4965,8 @@
         </p:nvSpPr>
         <p:spPr>
           <a:xfrm>
-            <a:off x="640080" y="1737360"/>
-            <a:ext cx="64008" cy="2057400"/>
+            <a:off x="640080" y="1874519"/>
+            <a:ext cx="64008" cy="1874519"/>
           </a:xfrm>
           <a:prstGeom prst="rect">
             <a:avLst/>
@@ -5217,7 +5010,7 @@
         </p:nvSpPr>
         <p:spPr>
           <a:xfrm>
-            <a:off x="859536" y="1901952"/>
+            <a:off x="859536" y="2057400"/>
             <a:ext cx="6217920" cy="320040"/>
           </a:xfrm>
           <a:prstGeom prst="rect">
@@ -5252,8 +5045,8 @@
         </p:nvSpPr>
         <p:spPr>
           <a:xfrm>
-            <a:off x="859536" y="2286000"/>
-            <a:ext cx="6217920" cy="1371600"/>
+            <a:off x="859536" y="2496312"/>
+            <a:ext cx="6217920" cy="1124712"/>
           </a:xfrm>
           <a:prstGeom prst="rect">
             <a:avLst/>
@@ -5268,13 +5061,13 @@
           <a:p>
             <a:pPr algn="l"/>
             <a:r>
-              <a:rPr sz="1400" b="0">
+              <a:rPr sz="1600" b="0">
                 <a:solidFill>
                   <a:srgbClr val="394252"/>
                 </a:solidFill>
                 <a:latin typeface="Aptos"/>
               </a:rPr>
-              <a:t>CLINISCOPE extracts text from PDF, TXT and DOCX records, identifies allergy, medication, diagnosis, lab, procedure and smoking statements with deterministic rules, compares them across the documents of one case, and flags potential discrepancies with verified source quotations for human review.</a:t>
+              <a:t>CLINISCOPE extracts text from PDF, TXT and DOCX records, finds allergy, medication, diagnosis and lab statements with rules, compares them across a case and flags potential conflicts with verified source quotes for human review.</a:t>
             </a:r>
           </a:p>
         </p:txBody>
@@ -5287,8 +5080,8 @@
         </p:nvSpPr>
         <p:spPr>
           <a:xfrm>
-            <a:off x="7498079" y="1737360"/>
-            <a:ext cx="4023360" cy="2057400"/>
+            <a:off x="7498079" y="1874519"/>
+            <a:ext cx="4023360" cy="1874519"/>
           </a:xfrm>
           <a:prstGeom prst="roundRect">
             <a:avLst>
@@ -5334,8 +5127,8 @@
         </p:nvSpPr>
         <p:spPr>
           <a:xfrm>
-            <a:off x="7498079" y="1737360"/>
-            <a:ext cx="64008" cy="2057400"/>
+            <a:off x="7498079" y="1874519"/>
+            <a:ext cx="64008" cy="1874519"/>
           </a:xfrm>
           <a:prstGeom prst="rect">
             <a:avLst/>
@@ -5379,7 +5172,7 @@
         </p:nvSpPr>
         <p:spPr>
           <a:xfrm>
-            <a:off x="7717536" y="1901952"/>
+            <a:off x="7717536" y="2057400"/>
             <a:ext cx="3611880" cy="320040"/>
           </a:xfrm>
           <a:prstGeom prst="rect">
@@ -5414,8 +5207,8 @@
         </p:nvSpPr>
         <p:spPr>
           <a:xfrm>
-            <a:off x="7717536" y="2286000"/>
-            <a:ext cx="3611880" cy="1371600"/>
+            <a:off x="7717536" y="2496312"/>
+            <a:ext cx="3611880" cy="1124712"/>
           </a:xfrm>
           <a:prstGeom prst="rect">
             <a:avLst/>
@@ -5430,13 +5223,13 @@
           <a:p>
             <a:pPr algn="l"/>
             <a:r>
-              <a:rPr sz="1250" b="0">
+              <a:rPr sz="1400" b="0">
                 <a:solidFill>
                   <a:srgbClr val="394252"/>
                 </a:solidFill>
                 <a:latin typeface="Aptos"/>
               </a:rPr>
-              <a:t>Every finding is traceable: it is created only if each quote is found again at its exact source offsets. Dated or documented changes are separated from true conflicts, and the final decision stays with the reviewer.</a:t>
+              <a:t>Every finding is traceable to an exact source quote. Dated or documented changes are separated from true conflicts, and people make the final call.</a:t>
             </a:r>
           </a:p>
         </p:txBody>
@@ -5449,8 +5242,8 @@
         </p:nvSpPr>
         <p:spPr>
           <a:xfrm>
-            <a:off x="640080" y="4023360"/>
-            <a:ext cx="3337560" cy="1463040"/>
+            <a:off x="640080" y="3977639"/>
+            <a:ext cx="3474720" cy="1417320"/>
           </a:xfrm>
           <a:prstGeom prst="roundRect">
             <a:avLst>
@@ -5496,8 +5289,8 @@
         </p:nvSpPr>
         <p:spPr>
           <a:xfrm>
-            <a:off x="640080" y="4023360"/>
-            <a:ext cx="64008" cy="1463040"/>
+            <a:off x="640080" y="3977639"/>
+            <a:ext cx="64008" cy="1417320"/>
           </a:xfrm>
           <a:prstGeom prst="rect">
             <a:avLst/>
@@ -5541,8 +5334,8 @@
         </p:nvSpPr>
         <p:spPr>
           <a:xfrm>
-            <a:off x="859536" y="4187952"/>
-            <a:ext cx="2926079" cy="320040"/>
+            <a:off x="859536" y="4160520"/>
+            <a:ext cx="3063239" cy="320040"/>
           </a:xfrm>
           <a:prstGeom prst="rect">
             <a:avLst/>
@@ -5563,7 +5356,7 @@
                 </a:solidFill>
                 <a:latin typeface="Aptos"/>
               </a:rPr>
-              <a:t>01  INGEST DOCUMENTS</a:t>
+              <a:t>01  DOCUMENT INGESTION</a:t>
             </a:r>
           </a:p>
         </p:txBody>
@@ -5576,8 +5369,8 @@
         </p:nvSpPr>
         <p:spPr>
           <a:xfrm>
-            <a:off x="859536" y="4572000"/>
-            <a:ext cx="2926079" cy="777240"/>
+            <a:off x="859536" y="4599431"/>
+            <a:ext cx="3063239" cy="667512"/>
           </a:xfrm>
           <a:prstGeom prst="rect">
             <a:avLst/>
@@ -5592,13 +5385,13 @@
           <a:p>
             <a:pPr algn="l"/>
             <a:r>
-              <a:rPr sz="1250" b="0">
+              <a:rPr sz="1300" b="0">
                 <a:solidFill>
                   <a:srgbClr val="394252"/>
                 </a:solidFill>
                 <a:latin typeface="Aptos"/>
               </a:rPr>
-              <a:t>PDF (text layer), TXT and DOCX are validated, de-duplicated and extracted in the browser.</a:t>
+              <a:t>PDF (text layer), TXT and DOCX are validated and extracted in the browser.</a:t>
             </a:r>
           </a:p>
         </p:txBody>
@@ -5611,8 +5404,8 @@
         </p:nvSpPr>
         <p:spPr>
           <a:xfrm>
-            <a:off x="4389120" y="4023360"/>
-            <a:ext cx="3337560" cy="1463040"/>
+            <a:off x="4343400" y="3977639"/>
+            <a:ext cx="3474720" cy="1417320"/>
           </a:xfrm>
           <a:prstGeom prst="roundRect">
             <a:avLst>
@@ -5658,8 +5451,8 @@
         </p:nvSpPr>
         <p:spPr>
           <a:xfrm>
-            <a:off x="4389120" y="4023360"/>
-            <a:ext cx="64008" cy="1463040"/>
+            <a:off x="4343400" y="3977639"/>
+            <a:ext cx="64008" cy="1417320"/>
           </a:xfrm>
           <a:prstGeom prst="rect">
             <a:avLst/>
@@ -5703,8 +5496,8 @@
         </p:nvSpPr>
         <p:spPr>
           <a:xfrm>
-            <a:off x="4608576" y="4187952"/>
-            <a:ext cx="2926079" cy="320040"/>
+            <a:off x="4562856" y="4160520"/>
+            <a:ext cx="3063239" cy="320040"/>
           </a:xfrm>
           <a:prstGeom prst="rect">
             <a:avLst/>
@@ -5725,7 +5518,7 @@
                 </a:solidFill>
                 <a:latin typeface="Aptos"/>
               </a:rPr>
-              <a:t>02  DETECT WITH EVIDENCE</a:t>
+              <a:t>02  EVIDENCE DETECTION</a:t>
             </a:r>
           </a:p>
         </p:txBody>
@@ -5738,8 +5531,8 @@
         </p:nvSpPr>
         <p:spPr>
           <a:xfrm>
-            <a:off x="4608576" y="4572000"/>
-            <a:ext cx="2926079" cy="777240"/>
+            <a:off x="4562856" y="4599431"/>
+            <a:ext cx="3063239" cy="667512"/>
           </a:xfrm>
           <a:prstGeom prst="rect">
             <a:avLst/>
@@ -5754,13 +5547,13 @@
           <a:p>
             <a:pPr algn="l"/>
             <a:r>
-              <a:rPr sz="1250" b="0">
+              <a:rPr sz="1300" b="0">
                 <a:solidFill>
                   <a:srgbClr val="394252"/>
                 </a:solidFill>
                 <a:latin typeface="Aptos"/>
               </a:rPr>
-              <a:t>Rules compare statements and label each difference by type, backed by quoted evidence.</a:t>
+              <a:t>Rule-based comparison flags potential conflicts with source quotes.</a:t>
             </a:r>
           </a:p>
         </p:txBody>
@@ -5773,8 +5566,8 @@
         </p:nvSpPr>
         <p:spPr>
           <a:xfrm>
-            <a:off x="8138160" y="4023360"/>
-            <a:ext cx="3337560" cy="1463040"/>
+            <a:off x="8046720" y="3977639"/>
+            <a:ext cx="3474720" cy="1417320"/>
           </a:xfrm>
           <a:prstGeom prst="roundRect">
             <a:avLst>
@@ -5820,8 +5613,8 @@
         </p:nvSpPr>
         <p:spPr>
           <a:xfrm>
-            <a:off x="8138160" y="4023360"/>
-            <a:ext cx="64008" cy="1463040"/>
+            <a:off x="8046720" y="3977639"/>
+            <a:ext cx="64008" cy="1417320"/>
           </a:xfrm>
           <a:prstGeom prst="rect">
             <a:avLst/>
@@ -5865,8 +5658,8 @@
         </p:nvSpPr>
         <p:spPr>
           <a:xfrm>
-            <a:off x="8357616" y="4187952"/>
-            <a:ext cx="2926079" cy="320040"/>
+            <a:off x="8266176" y="4160520"/>
+            <a:ext cx="3063239" cy="320040"/>
           </a:xfrm>
           <a:prstGeom prst="rect">
             <a:avLst/>
@@ -5900,8 +5693,8 @@
         </p:nvSpPr>
         <p:spPr>
           <a:xfrm>
-            <a:off x="8357616" y="4572000"/>
-            <a:ext cx="2926079" cy="777240"/>
+            <a:off x="8266176" y="4599431"/>
+            <a:ext cx="3063239" cy="667512"/>
           </a:xfrm>
           <a:prstGeom prst="rect">
             <a:avLst/>
@@ -5916,13 +5709,13 @@
           <a:p>
             <a:pPr algn="l"/>
             <a:r>
-              <a:rPr sz="1250" b="0">
+              <a:rPr sz="1300" b="0">
                 <a:solidFill>
                   <a:srgbClr val="394252"/>
                 </a:solidFill>
                 <a:latin typeface="Aptos"/>
               </a:rPr>
-              <a:t>Confirm, resolve or dismiss with a required reason; every action lands in an audit log.</a:t>
+              <a:t>Decisions need a reason; every action is kept in an audit log.</a:t>
             </a:r>
           </a:p>
         </p:txBody>
@@ -5935,8 +5728,8 @@
         </p:nvSpPr>
         <p:spPr>
           <a:xfrm>
-            <a:off x="777240" y="5669280"/>
-            <a:ext cx="10789920" cy="548640"/>
+            <a:off x="777240" y="5687568"/>
+            <a:ext cx="10789920" cy="320040"/>
           </a:xfrm>
           <a:prstGeom prst="rect">
             <a:avLst/>
@@ -5953,20 +5746,11 @@
             <a:r>
               <a:rPr sz="1400" b="1">
                 <a:solidFill>
-                  <a:srgbClr val="5369DC"/>
-                </a:solidFill>
-                <a:latin typeface="Aptos"/>
-              </a:rPr>
-              <a:t>EXPECTED BENEFIT:  </a:t>
-            </a:r>
-            <a:r>
-              <a:rPr sz="1400" b="0">
-                <a:solidFill>
                   <a:srgbClr val="162239"/>
                 </a:solidFill>
                 <a:latin typeface="Aptos"/>
               </a:rPr>
-              <a:t>Potential inconsistencies become easier to locate and investigate, while evidence traceability and human judgment are preserved.</a:t>
+              <a:t>EXPECTED BENEFIT:  Conflicts become easier to find and investigate, with evidence and human judgment kept.</a:t>
             </a:r>
           </a:p>
         </p:txBody>
@@ -6014,8 +5798,8 @@
         </p:nvSpPr>
         <p:spPr>
           <a:xfrm>
-            <a:off x="10744200" y="6473952"/>
-            <a:ext cx="822960" cy="201168"/>
+            <a:off x="11064240" y="6473952"/>
+            <a:ext cx="502920" cy="201168"/>
           </a:xfrm>
           <a:prstGeom prst="rect">
             <a:avLst/>
@@ -6037,76 +5821,6 @@
                 <a:latin typeface="Aptos"/>
               </a:rPr>
               <a:t>03 / 08</a:t>
-            </a:r>
-          </a:p>
-        </p:txBody>
-      </p:sp>
-      <p:sp>
-        <p:nvSpPr>
-          <p:cNvPr id="31" name="Flow Arrow"/>
-          <p:cNvSpPr txBox="1"/>
-          <p:nvPr/>
-        </p:nvSpPr>
-        <p:spPr>
-          <a:xfrm>
-            <a:off x="3995927" y="4526280"/>
-            <a:ext cx="411480" cy="365760"/>
-          </a:xfrm>
-          <a:prstGeom prst="rect">
-            <a:avLst/>
-          </a:prstGeom>
-          <a:noFill/>
-        </p:spPr>
-        <p:txBody>
-          <a:bodyPr wrap="square" anchor="t">
-            <a:spAutoFit/>
-          </a:bodyPr>
-          <a:lstStyle/>
-          <a:p>
-            <a:pPr algn="ctr"/>
-            <a:r>
-              <a:rPr sz="2200" b="1">
-                <a:solidFill>
-                  <a:srgbClr val="767F90"/>
-                </a:solidFill>
-                <a:latin typeface="Aptos"/>
-              </a:rPr>
-              <a:t>→</a:t>
-            </a:r>
-          </a:p>
-        </p:txBody>
-      </p:sp>
-      <p:sp>
-        <p:nvSpPr>
-          <p:cNvPr id="32" name="Flow Arrow"/>
-          <p:cNvSpPr txBox="1"/>
-          <p:nvPr/>
-        </p:nvSpPr>
-        <p:spPr>
-          <a:xfrm>
-            <a:off x="7744967" y="4526280"/>
-            <a:ext cx="411480" cy="365760"/>
-          </a:xfrm>
-          <a:prstGeom prst="rect">
-            <a:avLst/>
-          </a:prstGeom>
-          <a:noFill/>
-        </p:spPr>
-        <p:txBody>
-          <a:bodyPr wrap="square" anchor="t">
-            <a:spAutoFit/>
-          </a:bodyPr>
-          <a:lstStyle/>
-          <a:p>
-            <a:pPr algn="ctr"/>
-            <a:r>
-              <a:rPr sz="2200" b="1">
-                <a:solidFill>
-                  <a:srgbClr val="767F90"/>
-                </a:solidFill>
-                <a:latin typeface="Aptos"/>
-              </a:rPr>
-              <a:t>→</a:t>
             </a:r>
           </a:p>
         </p:txBody>
@@ -6237,7 +5951,7 @@
                 </a:solidFill>
                 <a:latin typeface="Aptos"/>
               </a:rPr>
-              <a:t>The whole pipeline runs in the reviewer's browser: there is no backend server, no AI/LLM and no OCR in the current build.</a:t>
+              <a:t>Everything runs in the reviewer's browser: no backend server, no AI/LLM and no OCR in the current build.</a:t>
             </a:r>
           </a:p>
         </p:txBody>
@@ -6385,8 +6099,8 @@
         </p:nvSpPr>
         <p:spPr>
           <a:xfrm>
-            <a:off x="685800" y="1783080"/>
-            <a:ext cx="1645920" cy="1325880"/>
+            <a:off x="685800" y="2057400"/>
+            <a:ext cx="1645920" cy="1051560"/>
           </a:xfrm>
           <a:prstGeom prst="roundRect">
             <a:avLst>
@@ -6432,8 +6146,8 @@
         </p:nvSpPr>
         <p:spPr>
           <a:xfrm>
-            <a:off x="749808" y="1901952"/>
-            <a:ext cx="1517904" cy="256032"/>
+            <a:off x="795528" y="2267712"/>
+            <a:ext cx="1426464" cy="256032"/>
           </a:xfrm>
           <a:prstGeom prst="rect">
             <a:avLst/>
@@ -6467,8 +6181,8 @@
         </p:nvSpPr>
         <p:spPr>
           <a:xfrm>
-            <a:off x="749808" y="2240280"/>
-            <a:ext cx="1517904" cy="777240"/>
+            <a:off x="795528" y="2633472"/>
+            <a:ext cx="1426464" cy="228600"/>
           </a:xfrm>
           <a:prstGeom prst="rect">
             <a:avLst/>
@@ -6481,51 +6195,15 @@
           </a:bodyPr>
           <a:lstStyle/>
           <a:p>
-            <a:pPr algn="ctr">
-              <a:spcAft>
-                <a:spcPts val="100"/>
-              </a:spcAft>
-            </a:pPr>
-            <a:r>
-              <a:rPr sz="1050" b="0">
+            <a:pPr algn="ctr"/>
+            <a:r>
+              <a:rPr sz="1000" b="0">
                 <a:solidFill>
                   <a:srgbClr val="394252"/>
                 </a:solidFill>
                 <a:latin typeface="Aptos"/>
               </a:rPr>
-              <a:t>PDF (text layer)</a:t>
-            </a:r>
-          </a:p>
-          <a:p>
-            <a:pPr algn="ctr">
-              <a:spcAft>
-                <a:spcPts val="100"/>
-              </a:spcAft>
-            </a:pPr>
-            <a:r>
-              <a:rPr sz="1050" b="0">
-                <a:solidFill>
-                  <a:srgbClr val="394252"/>
-                </a:solidFill>
-                <a:latin typeface="Aptos"/>
-              </a:rPr>
-              <a:t>TXT · DOCX</a:t>
-            </a:r>
-          </a:p>
-          <a:p>
-            <a:pPr algn="ctr">
-              <a:spcAft>
-                <a:spcPts val="100"/>
-              </a:spcAft>
-            </a:pPr>
-            <a:r>
-              <a:rPr sz="1050" b="0">
-                <a:solidFill>
-                  <a:srgbClr val="394252"/>
-                </a:solidFill>
-                <a:latin typeface="Aptos"/>
-              </a:rPr>
-              <a:t>Synthetic records</a:t>
+              <a:t>PDF · TXT · DOCX</a:t>
             </a:r>
           </a:p>
         </p:txBody>
@@ -6538,7 +6216,7 @@
         </p:nvSpPr>
         <p:spPr>
           <a:xfrm>
-            <a:off x="2404872" y="2212848"/>
+            <a:off x="2404872" y="2359152"/>
             <a:ext cx="502920" cy="320040"/>
           </a:xfrm>
           <a:prstGeom prst="rect">
@@ -6573,8 +6251,8 @@
         </p:nvSpPr>
         <p:spPr>
           <a:xfrm>
-            <a:off x="2971800" y="1783080"/>
-            <a:ext cx="1645920" cy="1325880"/>
+            <a:off x="2971800" y="2057400"/>
+            <a:ext cx="1645920" cy="1051560"/>
           </a:xfrm>
           <a:prstGeom prst="roundRect">
             <a:avLst>
@@ -6620,8 +6298,8 @@
         </p:nvSpPr>
         <p:spPr>
           <a:xfrm>
-            <a:off x="3035808" y="1901952"/>
-            <a:ext cx="1517904" cy="256032"/>
+            <a:off x="3081528" y="2267712"/>
+            <a:ext cx="1426464" cy="256032"/>
           </a:xfrm>
           <a:prstGeom prst="rect">
             <a:avLst/>
@@ -6655,8 +6333,8 @@
         </p:nvSpPr>
         <p:spPr>
           <a:xfrm>
-            <a:off x="3035808" y="2240280"/>
-            <a:ext cx="1517904" cy="777240"/>
+            <a:off x="3081528" y="2633472"/>
+            <a:ext cx="1426464" cy="228600"/>
           </a:xfrm>
           <a:prstGeom prst="rect">
             <a:avLst/>
@@ -6669,51 +6347,15 @@
           </a:bodyPr>
           <a:lstStyle/>
           <a:p>
-            <a:pPr algn="ctr">
-              <a:spcAft>
-                <a:spcPts val="100"/>
-              </a:spcAft>
-            </a:pPr>
-            <a:r>
-              <a:rPr sz="1050" b="0">
+            <a:pPr algn="ctr"/>
+            <a:r>
+              <a:rPr sz="1000" b="0">
                 <a:solidFill>
                   <a:srgbClr val="394252"/>
                 </a:solidFill>
                 <a:latin typeface="Aptos"/>
               </a:rPr>
               <a:t>React + TypeScript</a:t>
-            </a:r>
-          </a:p>
-          <a:p>
-            <a:pPr algn="ctr">
-              <a:spcAft>
-                <a:spcPts val="100"/>
-              </a:spcAft>
-            </a:pPr>
-            <a:r>
-              <a:rPr sz="1050" b="0">
-                <a:solidFill>
-                  <a:srgbClr val="394252"/>
-                </a:solidFill>
-                <a:latin typeface="Aptos"/>
-              </a:rPr>
-              <a:t>Library · Queue</a:t>
-            </a:r>
-          </a:p>
-          <a:p>
-            <a:pPr algn="ctr">
-              <a:spcAft>
-                <a:spcPts val="100"/>
-              </a:spcAft>
-            </a:pPr>
-            <a:r>
-              <a:rPr sz="1050" b="0">
-                <a:solidFill>
-                  <a:srgbClr val="394252"/>
-                </a:solidFill>
-                <a:latin typeface="Aptos"/>
-              </a:rPr>
-              <a:t>Finding detail</a:t>
             </a:r>
           </a:p>
         </p:txBody>
@@ -6726,7 +6368,7 @@
         </p:nvSpPr>
         <p:spPr>
           <a:xfrm>
-            <a:off x="4690872" y="2212848"/>
+            <a:off x="4690872" y="2359152"/>
             <a:ext cx="502920" cy="320040"/>
           </a:xfrm>
           <a:prstGeom prst="rect">
@@ -6761,8 +6403,8 @@
         </p:nvSpPr>
         <p:spPr>
           <a:xfrm>
-            <a:off x="5257800" y="1783080"/>
-            <a:ext cx="1645920" cy="1325880"/>
+            <a:off x="5257800" y="2057400"/>
+            <a:ext cx="1645920" cy="1051560"/>
           </a:xfrm>
           <a:prstGeom prst="roundRect">
             <a:avLst>
@@ -6808,8 +6450,8 @@
         </p:nvSpPr>
         <p:spPr>
           <a:xfrm>
-            <a:off x="5321808" y="1901952"/>
-            <a:ext cx="1517904" cy="256032"/>
+            <a:off x="5367528" y="2267712"/>
+            <a:ext cx="1426464" cy="256032"/>
           </a:xfrm>
           <a:prstGeom prst="rect">
             <a:avLst/>
@@ -6843,8 +6485,8 @@
         </p:nvSpPr>
         <p:spPr>
           <a:xfrm>
-            <a:off x="5321808" y="2240280"/>
-            <a:ext cx="1517904" cy="777240"/>
+            <a:off x="5367528" y="2633472"/>
+            <a:ext cx="1426464" cy="228600"/>
           </a:xfrm>
           <a:prstGeom prst="rect">
             <a:avLst/>
@@ -6857,45 +6499,9 @@
           </a:bodyPr>
           <a:lstStyle/>
           <a:p>
-            <a:pPr algn="ctr">
-              <a:spcAft>
-                <a:spcPts val="100"/>
-              </a:spcAft>
-            </a:pPr>
-            <a:r>
-              <a:rPr sz="1050" b="0">
-                <a:solidFill>
-                  <a:srgbClr val="394252"/>
-                </a:solidFill>
-                <a:latin typeface="Aptos"/>
-              </a:rPr>
-              <a:t>Validate · dedupe</a:t>
-            </a:r>
-          </a:p>
-          <a:p>
-            <a:pPr algn="ctr">
-              <a:spcAft>
-                <a:spcPts val="100"/>
-              </a:spcAft>
-            </a:pPr>
-            <a:r>
-              <a:rPr sz="1050" b="0">
-                <a:solidFill>
-                  <a:srgbClr val="394252"/>
-                </a:solidFill>
-                <a:latin typeface="Aptos"/>
-              </a:rPr>
-              <a:t>Analyze · review</a:t>
-            </a:r>
-          </a:p>
-          <a:p>
-            <a:pPr algn="ctr">
-              <a:spcAft>
-                <a:spcPts val="100"/>
-              </a:spcAft>
-            </a:pPr>
-            <a:r>
-              <a:rPr sz="1050" b="0">
+            <a:pPr algn="ctr"/>
+            <a:r>
+              <a:rPr sz="1000" b="0">
                 <a:solidFill>
                   <a:srgbClr val="394252"/>
                 </a:solidFill>
@@ -6914,7 +6520,7 @@
         </p:nvSpPr>
         <p:spPr>
           <a:xfrm>
-            <a:off x="6976872" y="2212848"/>
+            <a:off x="6976872" y="2359152"/>
             <a:ext cx="502920" cy="320040"/>
           </a:xfrm>
           <a:prstGeom prst="rect">
@@ -6949,8 +6555,8 @@
         </p:nvSpPr>
         <p:spPr>
           <a:xfrm>
-            <a:off x="7543800" y="1783080"/>
-            <a:ext cx="1645920" cy="1325880"/>
+            <a:off x="7543800" y="2057400"/>
+            <a:ext cx="1645920" cy="1051560"/>
           </a:xfrm>
           <a:prstGeom prst="roundRect">
             <a:avLst>
@@ -6996,8 +6602,8 @@
         </p:nvSpPr>
         <p:spPr>
           <a:xfrm>
-            <a:off x="7607808" y="1901952"/>
-            <a:ext cx="1517904" cy="256032"/>
+            <a:off x="7653527" y="2267712"/>
+            <a:ext cx="1426464" cy="256032"/>
           </a:xfrm>
           <a:prstGeom prst="rect">
             <a:avLst/>
@@ -7031,8 +6637,8 @@
         </p:nvSpPr>
         <p:spPr>
           <a:xfrm>
-            <a:off x="7607808" y="2240280"/>
-            <a:ext cx="1517904" cy="777240"/>
+            <a:off x="7653527" y="2633472"/>
+            <a:ext cx="1426464" cy="228600"/>
           </a:xfrm>
           <a:prstGeom prst="rect">
             <a:avLst/>
@@ -7045,51 +6651,15 @@
           </a:bodyPr>
           <a:lstStyle/>
           <a:p>
-            <a:pPr algn="ctr">
-              <a:spcAft>
-                <a:spcPts val="100"/>
-              </a:spcAft>
-            </a:pPr>
-            <a:r>
-              <a:rPr sz="1050" b="0">
+            <a:pPr algn="ctr"/>
+            <a:r>
+              <a:rPr sz="1000" b="0">
                 <a:solidFill>
                   <a:srgbClr val="394252"/>
                 </a:solidFill>
                 <a:latin typeface="Aptos"/>
               </a:rPr>
-              <a:t>Statement rules</a:t>
-            </a:r>
-          </a:p>
-          <a:p>
-            <a:pPr algn="ctr">
-              <a:spcAft>
-                <a:spcPts val="100"/>
-              </a:spcAft>
-            </a:pPr>
-            <a:r>
-              <a:rPr sz="1050" b="0">
-                <a:solidFill>
-                  <a:srgbClr val="394252"/>
-                </a:solidFill>
-                <a:latin typeface="Aptos"/>
-              </a:rPr>
-              <a:t>Conflict rules</a:t>
-            </a:r>
-          </a:p>
-          <a:p>
-            <a:pPr algn="ctr">
-              <a:spcAft>
-                <a:spcPts val="100"/>
-              </a:spcAft>
-            </a:pPr>
-            <a:r>
-              <a:rPr sz="1050" b="0">
-                <a:solidFill>
-                  <a:srgbClr val="394252"/>
-                </a:solidFill>
-                <a:latin typeface="Aptos"/>
-              </a:rPr>
-              <a:t>Evidence check</a:t>
+              <a:t>Rule-based engine</a:t>
             </a:r>
           </a:p>
         </p:txBody>
@@ -7102,7 +6672,7 @@
         </p:nvSpPr>
         <p:spPr>
           <a:xfrm>
-            <a:off x="9262872" y="2212848"/>
+            <a:off x="9262872" y="2359152"/>
             <a:ext cx="502920" cy="320040"/>
           </a:xfrm>
           <a:prstGeom prst="rect">
@@ -7137,8 +6707,8 @@
         </p:nvSpPr>
         <p:spPr>
           <a:xfrm>
-            <a:off x="9829800" y="1783080"/>
-            <a:ext cx="1645920" cy="1325880"/>
+            <a:off x="9829800" y="2057400"/>
+            <a:ext cx="1645920" cy="1051560"/>
           </a:xfrm>
           <a:prstGeom prst="roundRect">
             <a:avLst>
@@ -7184,8 +6754,8 @@
         </p:nvSpPr>
         <p:spPr>
           <a:xfrm>
-            <a:off x="9893808" y="1901952"/>
-            <a:ext cx="1517904" cy="256032"/>
+            <a:off x="9939528" y="2267712"/>
+            <a:ext cx="1426464" cy="256032"/>
           </a:xfrm>
           <a:prstGeom prst="rect">
             <a:avLst/>
@@ -7219,8 +6789,8 @@
         </p:nvSpPr>
         <p:spPr>
           <a:xfrm>
-            <a:off x="9893808" y="2240280"/>
-            <a:ext cx="1517904" cy="777240"/>
+            <a:off x="9939528" y="2633472"/>
+            <a:ext cx="1426464" cy="228600"/>
           </a:xfrm>
           <a:prstGeom prst="rect">
             <a:avLst/>
@@ -7233,51 +6803,15 @@
           </a:bodyPr>
           <a:lstStyle/>
           <a:p>
-            <a:pPr algn="ctr">
-              <a:spcAft>
-                <a:spcPts val="100"/>
-              </a:spcAft>
-            </a:pPr>
-            <a:r>
-              <a:rPr sz="1050" b="0">
+            <a:pPr algn="ctr"/>
+            <a:r>
+              <a:rPr sz="1000" b="0">
                 <a:solidFill>
                   <a:srgbClr val="394252"/>
                 </a:solidFill>
                 <a:latin typeface="Aptos"/>
               </a:rPr>
-              <a:t>Classified findings</a:t>
-            </a:r>
-          </a:p>
-          <a:p>
-            <a:pPr algn="ctr">
-              <a:spcAft>
-                <a:spcPts val="100"/>
-              </a:spcAft>
-            </a:pPr>
-            <a:r>
-              <a:rPr sz="1050" b="0">
-                <a:solidFill>
-                  <a:srgbClr val="394252"/>
-                </a:solidFill>
-                <a:latin typeface="Aptos"/>
-              </a:rPr>
-              <a:t>Quoted evidence</a:t>
-            </a:r>
-          </a:p>
-          <a:p>
-            <a:pPr algn="ctr">
-              <a:spcAft>
-                <a:spcPts val="100"/>
-              </a:spcAft>
-            </a:pPr>
-            <a:r>
-              <a:rPr sz="1050" b="0">
-                <a:solidFill>
-                  <a:srgbClr val="394252"/>
-                </a:solidFill>
-                <a:latin typeface="Aptos"/>
-              </a:rPr>
-              <a:t>Review + audit log</a:t>
+              <a:t>Evidence findings</a:t>
             </a:r>
           </a:p>
         </p:txBody>
@@ -7290,8 +6824,8 @@
         </p:nvSpPr>
         <p:spPr>
           <a:xfrm>
-            <a:off x="685800" y="3383280"/>
-            <a:ext cx="5349240" cy="2103120"/>
+            <a:off x="685800" y="3703320"/>
+            <a:ext cx="5349240" cy="1463040"/>
           </a:xfrm>
           <a:prstGeom prst="roundRect">
             <a:avLst>
@@ -7337,8 +6871,8 @@
         </p:nvSpPr>
         <p:spPr>
           <a:xfrm>
-            <a:off x="685800" y="3383280"/>
-            <a:ext cx="64008" cy="2103120"/>
+            <a:off x="685800" y="3703320"/>
+            <a:ext cx="64008" cy="1463040"/>
           </a:xfrm>
           <a:prstGeom prst="rect">
             <a:avLst/>
@@ -7382,7 +6916,7 @@
         </p:nvSpPr>
         <p:spPr>
           <a:xfrm>
-            <a:off x="905256" y="3547872"/>
+            <a:off x="905256" y="3886200"/>
             <a:ext cx="4937759" cy="320040"/>
           </a:xfrm>
           <a:prstGeom prst="rect">
@@ -7417,8 +6951,8 @@
         </p:nvSpPr>
         <p:spPr>
           <a:xfrm>
-            <a:off x="905256" y="3931920"/>
-            <a:ext cx="4937759" cy="1417319"/>
+            <a:off x="905256" y="4325112"/>
+            <a:ext cx="4937759" cy="713232"/>
           </a:xfrm>
           <a:prstGeom prst="rect">
             <a:avLst/>
@@ -7431,128 +6965,15 @@
           </a:bodyPr>
           <a:lstStyle/>
           <a:p>
-            <a:pPr algn="l">
-              <a:spcAft>
-                <a:spcPts val="200"/>
-              </a:spcAft>
-            </a:pPr>
-            <a:r>
-              <a:rPr sz="1250" b="1">
-                <a:solidFill>
-                  <a:srgbClr val="162239"/>
-                </a:solidFill>
-                <a:latin typeface="Aptos"/>
-              </a:rPr>
-              <a:t>1  Extraction: </a:t>
-            </a:r>
-            <a:r>
-              <a:rPr sz="1250" b="0">
+            <a:pPr algn="l"/>
+            <a:r>
+              <a:rPr sz="1400" b="0">
                 <a:solidFill>
                   <a:srgbClr val="394252"/>
                 </a:solidFill>
                 <a:latin typeface="Aptos"/>
               </a:rPr>
-              <a:t>pdf.js, mammoth, UTF-8 text with offsets</a:t>
-            </a:r>
-          </a:p>
-          <a:p>
-            <a:pPr algn="l">
-              <a:spcAft>
-                <a:spcPts val="200"/>
-              </a:spcAft>
-            </a:pPr>
-            <a:r>
-              <a:rPr sz="1250" b="1">
-                <a:solidFill>
-                  <a:srgbClr val="162239"/>
-                </a:solidFill>
-                <a:latin typeface="Aptos"/>
-              </a:rPr>
-              <a:t>2  Statements: </a:t>
-            </a:r>
-            <a:r>
-              <a:rPr sz="1250" b="0">
-                <a:solidFill>
-                  <a:srgbClr val="394252"/>
-                </a:solidFill>
-                <a:latin typeface="Aptos"/>
-              </a:rPr>
-              <a:t>negation, hedging, history, dose changes</a:t>
-            </a:r>
-          </a:p>
-          <a:p>
-            <a:pPr algn="l">
-              <a:spcAft>
-                <a:spcPts val="200"/>
-              </a:spcAft>
-            </a:pPr>
-            <a:r>
-              <a:rPr sz="1250" b="1">
-                <a:solidFill>
-                  <a:srgbClr val="162239"/>
-                </a:solidFill>
-                <a:latin typeface="Aptos"/>
-              </a:rPr>
-              <a:t>3  Detection: </a:t>
-            </a:r>
-            <a:r>
-              <a:rPr sz="1250" b="0">
-                <a:solidFill>
-                  <a:srgbClr val="394252"/>
-                </a:solidFill>
-                <a:latin typeface="Aptos"/>
-              </a:rPr>
-              <a:t>per-case comparison, units &amp; dates</a:t>
-            </a:r>
-          </a:p>
-          <a:p>
-            <a:pPr algn="l">
-              <a:spcAft>
-                <a:spcPts val="200"/>
-              </a:spcAft>
-            </a:pPr>
-            <a:r>
-              <a:rPr sz="1250" b="1">
-                <a:solidFill>
-                  <a:srgbClr val="162239"/>
-                </a:solidFill>
-                <a:latin typeface="Aptos"/>
-              </a:rPr>
-              <a:t>4  Evidence: </a:t>
-            </a:r>
-            <a:r>
-              <a:rPr sz="1250" b="0">
-                <a:solidFill>
-                  <a:srgbClr val="394252"/>
-                </a:solidFill>
-                <a:latin typeface="Aptos"/>
-              </a:rPr>
-              <a:t>quotes re-verified; View in source</a:t>
-            </a:r>
-          </a:p>
-          <a:p>
-            <a:pPr algn="l">
-              <a:spcAft>
-                <a:spcPts val="200"/>
-              </a:spcAft>
-            </a:pPr>
-            <a:r>
-              <a:rPr sz="1250" b="1">
-                <a:solidFill>
-                  <a:srgbClr val="162239"/>
-                </a:solidFill>
-                <a:latin typeface="Aptos"/>
-              </a:rPr>
-              <a:t>5  Review: </a:t>
-            </a:r>
-            <a:r>
-              <a:rPr sz="1250" b="0">
-                <a:solidFill>
-                  <a:srgbClr val="394252"/>
-                </a:solidFill>
-                <a:latin typeface="Aptos"/>
-              </a:rPr>
-              <a:t>state machine, notes, audit log</a:t>
+              <a:t>Extraction (pdf.js, mammoth) → statement rules → contradiction detection → evidence check → review workflow, stored with Dexie.</a:t>
             </a:r>
           </a:p>
         </p:txBody>
@@ -7565,8 +6986,8 @@
         </p:nvSpPr>
         <p:spPr>
           <a:xfrm>
-            <a:off x="6217920" y="3383280"/>
-            <a:ext cx="5303520" cy="2103120"/>
+            <a:off x="6217920" y="3703320"/>
+            <a:ext cx="5303520" cy="1463040"/>
           </a:xfrm>
           <a:prstGeom prst="roundRect">
             <a:avLst>
@@ -7612,8 +7033,8 @@
         </p:nvSpPr>
         <p:spPr>
           <a:xfrm>
-            <a:off x="6217920" y="3383280"/>
-            <a:ext cx="64008" cy="2103120"/>
+            <a:off x="6217920" y="3703320"/>
+            <a:ext cx="64008" cy="1463040"/>
           </a:xfrm>
           <a:prstGeom prst="rect">
             <a:avLst/>
@@ -7657,7 +7078,7 @@
         </p:nvSpPr>
         <p:spPr>
           <a:xfrm>
-            <a:off x="6437376" y="3547872"/>
+            <a:off x="6437376" y="3886200"/>
             <a:ext cx="4892040" cy="320040"/>
           </a:xfrm>
           <a:prstGeom prst="rect">
@@ -7692,8 +7113,8 @@
         </p:nvSpPr>
         <p:spPr>
           <a:xfrm>
-            <a:off x="6437376" y="3931920"/>
-            <a:ext cx="4892040" cy="1417319"/>
+            <a:off x="6437376" y="4325112"/>
+            <a:ext cx="4892040" cy="713232"/>
           </a:xfrm>
           <a:prstGeom prst="rect">
             <a:avLst/>
@@ -7706,123 +7127,15 @@
           </a:bodyPr>
           <a:lstStyle/>
           <a:p>
-            <a:pPr algn="l" marL="228600" indent="-228600">
-              <a:spcAft>
-                <a:spcPts val="200"/>
-              </a:spcAft>
-              <a:buClr>
-                <a:srgbClr val="2DA6A0"/>
-              </a:buClr>
-              <a:buFont typeface="Arial"/>
-              <a:buChar char="•"/>
-            </a:pPr>
-            <a:r>
-              <a:rPr sz="1250" b="1">
-                <a:solidFill>
-                  <a:srgbClr val="162239"/>
-                </a:solidFill>
-                <a:latin typeface="Aptos"/>
-              </a:rPr>
-              <a:t>Uploads: </a:t>
-            </a:r>
-            <a:r>
-              <a:rPr sz="1250" b="0">
+            <a:pPr algn="l"/>
+            <a:r>
+              <a:rPr sz="1400" b="0">
                 <a:solidFill>
                   <a:srgbClr val="394252"/>
                 </a:solidFill>
                 <a:latin typeface="Aptos"/>
               </a:rPr>
-              <a:t>type, magic-byte and size checks; dedupe</a:t>
-            </a:r>
-          </a:p>
-          <a:p>
-            <a:pPr algn="l" marL="228600" indent="-228600">
-              <a:spcAft>
-                <a:spcPts val="200"/>
-              </a:spcAft>
-              <a:buClr>
-                <a:srgbClr val="2DA6A0"/>
-              </a:buClr>
-              <a:buFont typeface="Arial"/>
-              <a:buChar char="•"/>
-            </a:pPr>
-            <a:r>
-              <a:rPr sz="1250" b="1">
-                <a:solidFill>
-                  <a:srgbClr val="162239"/>
-                </a:solidFill>
-                <a:latin typeface="Aptos"/>
-              </a:rPr>
-              <a:t>Findings: </a:t>
-            </a:r>
-            <a:r>
-              <a:rPr sz="1250" b="0">
-                <a:solidFill>
-                  <a:srgbClr val="394252"/>
-                </a:solidFill>
-                <a:latin typeface="Aptos"/>
-              </a:rPr>
-              <a:t>only if every quote matches its source</a:t>
-            </a:r>
-          </a:p>
-          <a:p>
-            <a:pPr algn="l" marL="228600" indent="-228600">
-              <a:spcAft>
-                <a:spcPts val="200"/>
-              </a:spcAft>
-              <a:buClr>
-                <a:srgbClr val="2DA6A0"/>
-              </a:buClr>
-              <a:buFont typeface="Arial"/>
-              <a:buChar char="•"/>
-            </a:pPr>
-            <a:r>
-              <a:rPr sz="1250" b="1">
-                <a:solidFill>
-                  <a:srgbClr val="162239"/>
-                </a:solidFill>
-                <a:latin typeface="Aptos"/>
-              </a:rPr>
-              <a:t>Dates: </a:t>
-            </a:r>
-            <a:r>
-              <a:rPr sz="1250" b="0">
-                <a:solidFill>
-                  <a:srgbClr val="394252"/>
-                </a:solidFill>
-                <a:latin typeface="Aptos"/>
-              </a:rPr>
-              <a:t>specimen dates and dose changes reclassify</a:t>
-            </a:r>
-          </a:p>
-          <a:p>
-            <a:pPr algn="l" marL="228600" indent="-228600">
-              <a:spcAft>
-                <a:spcPts val="200"/>
-              </a:spcAft>
-              <a:buClr>
-                <a:srgbClr val="2DA6A0"/>
-              </a:buClr>
-              <a:buFont typeface="Arial"/>
-              <a:buChar char="•"/>
-            </a:pPr>
-            <a:r>
-              <a:rPr sz="1250" b="1">
-                <a:solidFill>
-                  <a:srgbClr val="162239"/>
-                </a:solidFill>
-                <a:latin typeface="Aptos"/>
-              </a:rPr>
-              <a:t>Scanned PDFs: </a:t>
-            </a:r>
-            <a:r>
-              <a:rPr sz="1250" b="0">
-                <a:solidFill>
-                  <a:srgbClr val="394252"/>
-                </a:solidFill>
-                <a:latin typeface="Aptos"/>
-              </a:rPr>
-              <a:t>flagged; every decision needs a reason</a:t>
+              <a:t>Uploads are type- and size-checked. A finding is kept only if its quotes match the source text; dates can reclassify it.</a:t>
             </a:r>
           </a:p>
         </p:txBody>
@@ -7835,8 +7148,8 @@
         </p:nvSpPr>
         <p:spPr>
           <a:xfrm>
-            <a:off x="777240" y="5669280"/>
-            <a:ext cx="10698480" cy="548640"/>
+            <a:off x="777240" y="5532120"/>
+            <a:ext cx="10698480" cy="384048"/>
           </a:xfrm>
           <a:prstGeom prst="rect">
             <a:avLst/>
@@ -7853,20 +7166,11 @@
             <a:r>
               <a:rPr sz="1400" b="1">
                 <a:solidFill>
-                  <a:srgbClr val="5369DC"/>
-                </a:solidFill>
-                <a:latin typeface="Aptos"/>
-              </a:rPr>
-              <a:t>ARCHITECTURE NOTE:  </a:t>
-            </a:r>
-            <a:r>
-              <a:rPr sz="1400" b="0">
-                <a:solidFill>
                   <a:srgbClr val="162239"/>
                 </a:solidFill>
                 <a:latin typeface="Aptos"/>
               </a:rPr>
-              <a:t>Extraction, statement rules, detection and review are separate TypeScript modules with unit tests, so each stage can be tested and replaced independently.</a:t>
+              <a:t>ARCHITECTURE NOTE:  Extraction, detection and review are separate, unit-tested modules.</a:t>
             </a:r>
           </a:p>
         </p:txBody>
@@ -7914,8 +7218,8 @@
         </p:nvSpPr>
         <p:spPr>
           <a:xfrm>
-            <a:off x="10744200" y="6473952"/>
-            <a:ext cx="822960" cy="201168"/>
+            <a:off x="11064240" y="6473952"/>
+            <a:ext cx="502920" cy="201168"/>
           </a:xfrm>
           <a:prstGeom prst="rect">
             <a:avLst/>
@@ -8067,7 +7371,7 @@
                 </a:solidFill>
                 <a:latin typeface="Aptos"/>
               </a:rPr>
-              <a:t>Verified against package.json and the CI workflow. No Python, server framework, cloud database, OCR or LLM provider is used.</a:t>
+              <a:t>Technologies verified in package.json and the CI workflow, and the role each one plays.</a:t>
             </a:r>
           </a:p>
         </p:txBody>
@@ -8215,8 +7519,8 @@
         </p:nvSpPr>
         <p:spPr>
           <a:xfrm>
-            <a:off x="640080" y="1737360"/>
-            <a:ext cx="3474720" cy="1463040"/>
+            <a:off x="640080" y="1874519"/>
+            <a:ext cx="3474720" cy="1371600"/>
           </a:xfrm>
           <a:prstGeom prst="roundRect">
             <a:avLst>
@@ -8262,8 +7566,8 @@
         </p:nvSpPr>
         <p:spPr>
           <a:xfrm>
-            <a:off x="640080" y="1737360"/>
-            <a:ext cx="64008" cy="1463040"/>
+            <a:off x="640080" y="1874519"/>
+            <a:ext cx="64008" cy="1371600"/>
           </a:xfrm>
           <a:prstGeom prst="rect">
             <a:avLst/>
@@ -8307,7 +7611,7 @@
         </p:nvSpPr>
         <p:spPr>
           <a:xfrm>
-            <a:off x="859536" y="1901952"/>
+            <a:off x="859536" y="2057400"/>
             <a:ext cx="3063239" cy="320040"/>
           </a:xfrm>
           <a:prstGeom prst="rect">
@@ -8342,8 +7646,8 @@
         </p:nvSpPr>
         <p:spPr>
           <a:xfrm>
-            <a:off x="859536" y="2286000"/>
-            <a:ext cx="3063239" cy="777240"/>
+            <a:off x="859536" y="2496312"/>
+            <a:ext cx="3063239" cy="621792"/>
           </a:xfrm>
           <a:prstGeom prst="rect">
             <a:avLst/>
@@ -8364,7 +7668,7 @@
                 </a:solidFill>
                 <a:latin typeface="Aptos"/>
               </a:rPr>
-              <a:t>React 18 + TypeScript, built with Vite and styled with Tailwind CSS.</a:t>
+              <a:t>React 18, TypeScript, Vite and Tailwind CSS for the review UI.</a:t>
             </a:r>
           </a:p>
         </p:txBody>
@@ -8377,8 +7681,8 @@
         </p:nvSpPr>
         <p:spPr>
           <a:xfrm>
-            <a:off x="4343400" y="1737360"/>
-            <a:ext cx="3474720" cy="1463040"/>
+            <a:off x="4343400" y="1874519"/>
+            <a:ext cx="3474720" cy="1371600"/>
           </a:xfrm>
           <a:prstGeom prst="roundRect">
             <a:avLst>
@@ -8424,8 +7728,8 @@
         </p:nvSpPr>
         <p:spPr>
           <a:xfrm>
-            <a:off x="4343400" y="1737360"/>
-            <a:ext cx="64008" cy="1463040"/>
+            <a:off x="4343400" y="1874519"/>
+            <a:ext cx="64008" cy="1371600"/>
           </a:xfrm>
           <a:prstGeom prst="rect">
             <a:avLst/>
@@ -8469,7 +7773,7 @@
         </p:nvSpPr>
         <p:spPr>
           <a:xfrm>
-            <a:off x="4562856" y="1901952"/>
+            <a:off x="4562856" y="2057400"/>
             <a:ext cx="3063239" cy="320040"/>
           </a:xfrm>
           <a:prstGeom prst="rect">
@@ -8491,7 +7795,7 @@
                 </a:solidFill>
                 <a:latin typeface="Aptos"/>
               </a:rPr>
-              <a:t>BACKEND: NONE</a:t>
+              <a:t>BACKEND</a:t>
             </a:r>
           </a:p>
         </p:txBody>
@@ -8504,8 +7808,8 @@
         </p:nvSpPr>
         <p:spPr>
           <a:xfrm>
-            <a:off x="4562856" y="2286000"/>
-            <a:ext cx="3063239" cy="777240"/>
+            <a:off x="4562856" y="2496312"/>
+            <a:ext cx="3063239" cy="621792"/>
           </a:xfrm>
           <a:prstGeom prst="rect">
             <a:avLst/>
@@ -8526,7 +7830,7 @@
                 </a:solidFill>
                 <a:latin typeface="Aptos"/>
               </a:rPr>
-              <a:t>A TypeScript service layer in the browser runs upload, analysis and review.</a:t>
+              <a:t>None: a browser-side TypeScript service layer runs the workflow.</a:t>
             </a:r>
           </a:p>
         </p:txBody>
@@ -8539,8 +7843,8 @@
         </p:nvSpPr>
         <p:spPr>
           <a:xfrm>
-            <a:off x="8046720" y="1737360"/>
-            <a:ext cx="3474720" cy="1463040"/>
+            <a:off x="8046720" y="1874519"/>
+            <a:ext cx="3474720" cy="1371600"/>
           </a:xfrm>
           <a:prstGeom prst="roundRect">
             <a:avLst>
@@ -8586,8 +7890,8 @@
         </p:nvSpPr>
         <p:spPr>
           <a:xfrm>
-            <a:off x="8046720" y="1737360"/>
-            <a:ext cx="64008" cy="1463040"/>
+            <a:off x="8046720" y="1874519"/>
+            <a:ext cx="64008" cy="1371600"/>
           </a:xfrm>
           <a:prstGeom prst="rect">
             <a:avLst/>
@@ -8631,7 +7935,7 @@
         </p:nvSpPr>
         <p:spPr>
           <a:xfrm>
-            <a:off x="8266176" y="1901952"/>
+            <a:off x="8266176" y="2057400"/>
             <a:ext cx="3063239" cy="320040"/>
           </a:xfrm>
           <a:prstGeom prst="rect">
@@ -8653,7 +7957,7 @@
                 </a:solidFill>
                 <a:latin typeface="Aptos"/>
               </a:rPr>
-              <a:t>STORAGE</a:t>
+              <a:t>DATABASE</a:t>
             </a:r>
           </a:p>
         </p:txBody>
@@ -8666,8 +7970,8 @@
         </p:nvSpPr>
         <p:spPr>
           <a:xfrm>
-            <a:off x="8266176" y="2286000"/>
-            <a:ext cx="3063239" cy="777240"/>
+            <a:off x="8266176" y="2496312"/>
+            <a:ext cx="3063239" cy="621792"/>
           </a:xfrm>
           <a:prstGeom prst="rect">
             <a:avLst/>
@@ -8688,7 +7992,7 @@
                 </a:solidFill>
                 <a:latin typeface="Aptos"/>
               </a:rPr>
-              <a:t>IndexedDB via Dexie: cases, documents, original files, findings and audit events.</a:t>
+              <a:t>IndexedDB via Dexie: cases, files, findings and audit events.</a:t>
             </a:r>
           </a:p>
         </p:txBody>
@@ -8701,8 +8005,8 @@
         </p:nvSpPr>
         <p:spPr>
           <a:xfrm>
-            <a:off x="640080" y="3429000"/>
-            <a:ext cx="3474720" cy="1463040"/>
+            <a:off x="640080" y="3566160"/>
+            <a:ext cx="3474720" cy="1371600"/>
           </a:xfrm>
           <a:prstGeom prst="roundRect">
             <a:avLst>
@@ -8748,8 +8052,8 @@
         </p:nvSpPr>
         <p:spPr>
           <a:xfrm>
-            <a:off x="640080" y="3429000"/>
-            <a:ext cx="64008" cy="1463040"/>
+            <a:off x="640080" y="3566160"/>
+            <a:ext cx="64008" cy="1371600"/>
           </a:xfrm>
           <a:prstGeom prst="rect">
             <a:avLst/>
@@ -8793,7 +8097,7 @@
         </p:nvSpPr>
         <p:spPr>
           <a:xfrm>
-            <a:off x="859536" y="3593592"/>
+            <a:off x="859536" y="3749039"/>
             <a:ext cx="3063239" cy="320040"/>
           </a:xfrm>
           <a:prstGeom prst="rect">
@@ -8815,7 +8119,7 @@
                 </a:solidFill>
                 <a:latin typeface="Aptos"/>
               </a:rPr>
-              <a:t>CORE LOGIC (RULES)</a:t>
+              <a:t>AI / CORE LOGIC</a:t>
             </a:r>
           </a:p>
         </p:txBody>
@@ -8828,8 +8132,8 @@
         </p:nvSpPr>
         <p:spPr>
           <a:xfrm>
-            <a:off x="859536" y="3977639"/>
-            <a:ext cx="3063239" cy="777240"/>
+            <a:off x="859536" y="4187952"/>
+            <a:ext cx="3063239" cy="621792"/>
           </a:xfrm>
           <a:prstGeom prst="rect">
             <a:avLst/>
@@ -8850,7 +8154,7 @@
                 </a:solidFill>
                 <a:latin typeface="Aptos"/>
               </a:rPr>
-              <a:t>Deterministic TypeScript rules: vocabulary, negation, units and date handling.</a:t>
+              <a:t>No AI/LLM: deterministic TypeScript rules for detection.</a:t>
             </a:r>
           </a:p>
         </p:txBody>
@@ -8863,8 +8167,8 @@
         </p:nvSpPr>
         <p:spPr>
           <a:xfrm>
-            <a:off x="4343400" y="3429000"/>
-            <a:ext cx="3474720" cy="1463040"/>
+            <a:off x="4343400" y="3566160"/>
+            <a:ext cx="3474720" cy="1371600"/>
           </a:xfrm>
           <a:prstGeom prst="roundRect">
             <a:avLst>
@@ -8910,8 +8214,8 @@
         </p:nvSpPr>
         <p:spPr>
           <a:xfrm>
-            <a:off x="4343400" y="3429000"/>
-            <a:ext cx="64008" cy="1463040"/>
+            <a:off x="4343400" y="3566160"/>
+            <a:ext cx="64008" cy="1371600"/>
           </a:xfrm>
           <a:prstGeom prst="rect">
             <a:avLst/>
@@ -8955,7 +8259,7 @@
         </p:nvSpPr>
         <p:spPr>
           <a:xfrm>
-            <a:off x="4562856" y="3593592"/>
+            <a:off x="4562856" y="3749039"/>
             <a:ext cx="3063239" cy="320040"/>
           </a:xfrm>
           <a:prstGeom prst="rect">
@@ -8977,7 +8281,7 @@
                 </a:solidFill>
                 <a:latin typeface="Aptos"/>
               </a:rPr>
-              <a:t>DOCUMENT PROCESSING</a:t>
+              <a:t>INTEGRATIONS</a:t>
             </a:r>
           </a:p>
         </p:txBody>
@@ -8990,8 +8294,8 @@
         </p:nvSpPr>
         <p:spPr>
           <a:xfrm>
-            <a:off x="4562856" y="3977639"/>
-            <a:ext cx="3063239" cy="777240"/>
+            <a:off x="4562856" y="4187952"/>
+            <a:ext cx="3063239" cy="621792"/>
           </a:xfrm>
           <a:prstGeom prst="rect">
             <a:avLst/>
@@ -9012,7 +8316,7 @@
                 </a:solidFill>
                 <a:latin typeface="Aptos"/>
               </a:rPr>
-              <a:t>pdfjs-dist reads PDF text layers, mammoth reads DOCX; TXT read as UTF-8.</a:t>
+              <a:t>No external APIs. pdfjs-dist (PDF) and mammoth (DOCX) run locally.</a:t>
             </a:r>
           </a:p>
         </p:txBody>
@@ -9025,8 +8329,8 @@
         </p:nvSpPr>
         <p:spPr>
           <a:xfrm>
-            <a:off x="8046720" y="3429000"/>
-            <a:ext cx="3474720" cy="1463040"/>
+            <a:off x="8046720" y="3566160"/>
+            <a:ext cx="3474720" cy="1371600"/>
           </a:xfrm>
           <a:prstGeom prst="roundRect">
             <a:avLst>
@@ -9072,8 +8376,8 @@
         </p:nvSpPr>
         <p:spPr>
           <a:xfrm>
-            <a:off x="8046720" y="3429000"/>
-            <a:ext cx="64008" cy="1463040"/>
+            <a:off x="8046720" y="3566160"/>
+            <a:ext cx="64008" cy="1371600"/>
           </a:xfrm>
           <a:prstGeom prst="rect">
             <a:avLst/>
@@ -9117,7 +8421,7 @@
         </p:nvSpPr>
         <p:spPr>
           <a:xfrm>
-            <a:off x="8266176" y="3593592"/>
+            <a:off x="8266176" y="3749039"/>
             <a:ext cx="3063239" cy="320040"/>
           </a:xfrm>
           <a:prstGeom prst="rect">
@@ -9139,7 +8443,7 @@
                 </a:solidFill>
                 <a:latin typeface="Aptos"/>
               </a:rPr>
-              <a:t>TESTING &amp; DEPLOYMENT</a:t>
+              <a:t>DEPLOYMENT &amp; TOOLS</a:t>
             </a:r>
           </a:p>
         </p:txBody>
@@ -9152,8 +8456,8 @@
         </p:nvSpPr>
         <p:spPr>
           <a:xfrm>
-            <a:off x="8266176" y="3977639"/>
-            <a:ext cx="3063239" cy="777240"/>
+            <a:off x="8266176" y="4187952"/>
+            <a:ext cx="3063239" cy="621792"/>
           </a:xfrm>
           <a:prstGeom prst="rect">
             <a:avLst/>
@@ -9174,7 +8478,7 @@
                 </a:solidFill>
                 <a:latin typeface="Aptos"/>
               </a:rPr>
-              <a:t>Vitest + Playwright in GitHub Actions; static build hosted on GitHub Pages.</a:t>
+              <a:t>Git, GitHub Actions (Vitest, Playwright) and GitHub Pages.</a:t>
             </a:r>
           </a:p>
         </p:txBody>
@@ -9187,8 +8491,8 @@
         </p:nvSpPr>
         <p:spPr>
           <a:xfrm>
-            <a:off x="777240" y="5166360"/>
-            <a:ext cx="10607040" cy="822960"/>
+            <a:off x="777240" y="5321808"/>
+            <a:ext cx="10607040" cy="548640"/>
           </a:xfrm>
           <a:prstGeom prst="rect">
             <a:avLst/>
@@ -9205,20 +8509,11 @@
             <a:r>
               <a:rPr sz="1400" b="1">
                 <a:solidFill>
-                  <a:srgbClr val="5369DC"/>
-                </a:solidFill>
-                <a:latin typeface="Aptos"/>
-              </a:rPr>
-              <a:t>WHY THIS STACK?  </a:t>
-            </a:r>
-            <a:r>
-              <a:rPr sz="1400" b="0">
-                <a:solidFill>
                   <a:srgbClr val="162239"/>
                 </a:solidFill>
                 <a:latin typeface="Aptos"/>
               </a:rPr>
-              <a:t>A lightweight, testable static web app: documents are processed and stored in the reviewer's own browser, so no server or credentials are needed. A backend, OCR or AI service would be added only when the implementation requires it.</a:t>
+              <a:t>WHY THIS STACK?  A light, testable static web app: records are processed and stored in the browser, so no server is needed. OCR, AI or a backend would be added only when required.</a:t>
             </a:r>
           </a:p>
         </p:txBody>
@@ -9266,8 +8561,8 @@
         </p:nvSpPr>
         <p:spPr>
           <a:xfrm>
-            <a:off x="10744200" y="6473952"/>
-            <a:ext cx="822960" cy="201168"/>
+            <a:off x="11064240" y="6473952"/>
+            <a:ext cx="502920" cy="201168"/>
           </a:xfrm>
           <a:prstGeom prst="rect">
             <a:avLst/>
@@ -9419,7 +8714,7 @@
                 </a:solidFill>
                 <a:latin typeface="Aptos"/>
               </a:rPr>
-              <a:t>A working, tested prototype today, with a staged and cautious path toward real-world evaluation.</a:t>
+              <a:t>A working, tested prototype today, with a staged and cautious path toward real-world use.</a:t>
             </a:r>
           </a:p>
         </p:txBody>
@@ -9567,8 +8862,8 @@
         </p:nvSpPr>
         <p:spPr>
           <a:xfrm>
-            <a:off x="640080" y="1737360"/>
-            <a:ext cx="5349240" cy="3566160"/>
+            <a:off x="640080" y="1874519"/>
+            <a:ext cx="5349240" cy="3429000"/>
           </a:xfrm>
           <a:prstGeom prst="roundRect">
             <a:avLst>
@@ -9614,8 +8909,8 @@
         </p:nvSpPr>
         <p:spPr>
           <a:xfrm>
-            <a:off x="6217920" y="1737360"/>
-            <a:ext cx="5303520" cy="3566160"/>
+            <a:off x="6217920" y="1874519"/>
+            <a:ext cx="5303520" cy="3429000"/>
           </a:xfrm>
           <a:prstGeom prst="roundRect">
             <a:avLst>
@@ -9661,7 +8956,7 @@
         </p:nvSpPr>
         <p:spPr>
           <a:xfrm>
-            <a:off x="640080" y="1737360"/>
+            <a:off x="640080" y="1874519"/>
             <a:ext cx="5349240" cy="502920"/>
           </a:xfrm>
           <a:prstGeom prst="roundRect">
@@ -9708,7 +9003,7 @@
         </p:nvSpPr>
         <p:spPr>
           <a:xfrm>
-            <a:off x="6217920" y="1737360"/>
+            <a:off x="6217920" y="1874519"/>
             <a:ext cx="5303520" cy="502920"/>
           </a:xfrm>
           <a:prstGeom prst="roundRect">
@@ -9755,7 +9050,7 @@
         </p:nvSpPr>
         <p:spPr>
           <a:xfrm>
-            <a:off x="868680" y="1837943"/>
+            <a:off x="868680" y="1975104"/>
             <a:ext cx="4754880" cy="228600"/>
           </a:xfrm>
           <a:prstGeom prst="rect">
@@ -9790,7 +9085,7 @@
         </p:nvSpPr>
         <p:spPr>
           <a:xfrm>
-            <a:off x="6446520" y="1837943"/>
+            <a:off x="6446520" y="1975104"/>
             <a:ext cx="4754880" cy="228600"/>
           </a:xfrm>
           <a:prstGeom prst="rect">
@@ -9825,8 +9120,8 @@
         </p:nvSpPr>
         <p:spPr>
           <a:xfrm>
-            <a:off x="868680" y="2395728"/>
-            <a:ext cx="4937760" cy="2834640"/>
+            <a:off x="914400" y="2633472"/>
+            <a:ext cx="4754880" cy="2286000"/>
           </a:xfrm>
           <a:prstGeom prst="rect">
             <a:avLst/>
@@ -9839,123 +9134,87 @@
           </a:bodyPr>
           <a:lstStyle/>
           <a:p>
-            <a:pPr algn="l" marL="228600" indent="-228600">
-              <a:spcAft>
-                <a:spcPts val="900"/>
-              </a:spcAft>
-              <a:buClr>
-                <a:srgbClr val="2DA6A0"/>
-              </a:buClr>
-              <a:buFont typeface="Arial"/>
-              <a:buChar char="•"/>
-            </a:pPr>
-            <a:r>
-              <a:rPr sz="1350" b="1">
-                <a:solidFill>
-                  <a:srgbClr val="162239"/>
-                </a:solidFill>
-                <a:latin typeface="Aptos"/>
-              </a:rPr>
-              <a:t>Tools &amp; skills: </a:t>
-            </a:r>
-            <a:r>
-              <a:rPr sz="1350" b="0">
+            <a:pPr algn="l"/>
+            <a:r>
+              <a:rPr sz="1400" b="0">
                 <a:solidFill>
                   <a:srgbClr val="394252"/>
                 </a:solidFill>
                 <a:latin typeface="Aptos"/>
               </a:rPr>
-              <a:t>React, TypeScript, rule design, pdf.js / mammoth, Vitest and Playwright, all in use today.</a:t>
-            </a:r>
-          </a:p>
-          <a:p>
-            <a:pPr algn="l" marL="228600" indent="-228600">
-              <a:spcAft>
-                <a:spcPts val="900"/>
-              </a:spcAft>
-              <a:buClr>
-                <a:srgbClr val="2DA6A0"/>
-              </a:buClr>
-              <a:buFont typeface="Arial"/>
-              <a:buChar char="•"/>
-            </a:pPr>
-            <a:r>
-              <a:rPr sz="1350" b="1">
-                <a:solidFill>
-                  <a:srgbClr val="162239"/>
-                </a:solidFill>
-                <a:latin typeface="Aptos"/>
-              </a:rPr>
-              <a:t>Data &amp; infrastructure: </a:t>
-            </a:r>
-            <a:r>
-              <a:rPr sz="1350" b="0">
+              <a:t>• Required tools and skills: React, TypeScript, rule design, pdf.js, mammoth, Vitest, Playwright.</a:t>
+            </a:r>
+          </a:p>
+          <a:p>
+            <a:pPr algn="l"/>
+            <a:r>
+              <a:rPr sz="1400" b="0">
                 <a:solidFill>
                   <a:srgbClr val="394252"/>
                 </a:solidFill>
                 <a:latin typeface="Aptos"/>
               </a:rPr>
-              <a:t>synthetic demo records and browser storage only; no hospital systems or real patient data.</a:t>
-            </a:r>
-          </a:p>
-          <a:p>
-            <a:pPr algn="l" marL="228600" indent="-228600">
-              <a:spcAft>
-                <a:spcPts val="900"/>
-              </a:spcAft>
-              <a:buClr>
-                <a:srgbClr val="2DA6A0"/>
-              </a:buClr>
-              <a:buFont typeface="Arial"/>
-              <a:buChar char="•"/>
-            </a:pPr>
-            <a:r>
-              <a:rPr sz="1350" b="1">
-                <a:solidFill>
-                  <a:srgbClr val="162239"/>
-                </a:solidFill>
-                <a:latin typeface="Aptos"/>
-              </a:rPr>
-              <a:t>Status &amp; constraints: </a:t>
-            </a:r>
-            <a:r>
-              <a:rPr sz="1350" b="0">
+              <a:t/>
+            </a:r>
+          </a:p>
+          <a:p>
+            <a:pPr algn="l"/>
+            <a:r>
+              <a:rPr sz="1400" b="0">
                 <a:solidFill>
                   <a:srgbClr val="394252"/>
                 </a:solidFill>
                 <a:latin typeface="Aptos"/>
               </a:rPr>
-              <a:t>deployed prototype; 34 unit + 8 end-to-end tests pass. Limited vocabulary, no OCR, no login.</a:t>
-            </a:r>
-          </a:p>
-          <a:p>
-            <a:pPr algn="l" marL="228600" indent="-228600">
-              <a:spcAft>
-                <a:spcPts val="900"/>
-              </a:spcAft>
-              <a:buClr>
-                <a:srgbClr val="2DA6A0"/>
-              </a:buClr>
-              <a:buFont typeface="Arial"/>
-              <a:buChar char="•"/>
-            </a:pPr>
-            <a:r>
-              <a:rPr sz="1350" b="1">
-                <a:solidFill>
-                  <a:srgbClr val="162239"/>
-                </a:solidFill>
-                <a:latin typeface="Aptos"/>
-              </a:rPr>
-              <a:t>Risk → mitigation: </a:t>
-            </a:r>
-            <a:r>
-              <a:rPr sz="1350" b="0">
+              <a:t>• Data / infrastructure: synthetic records and browser storage only; no real patient data.</a:t>
+            </a:r>
+          </a:p>
+          <a:p>
+            <a:pPr algn="l"/>
+            <a:r>
+              <a:rPr sz="1400" b="0">
                 <a:solidFill>
                   <a:srgbClr val="394252"/>
                 </a:solidFill>
                 <a:latin typeface="Aptos"/>
               </a:rPr>
-              <a:t>mis-extraction and context false positives → offset-verified quotes, uncertainty labels, human review, regression tests.</a:t>
+              <a:t/>
+            </a:r>
+          </a:p>
+          <a:p>
+            <a:pPr algn="l"/>
+            <a:r>
+              <a:rPr sz="1400" b="0">
+                <a:solidFill>
+                  <a:srgbClr val="394252"/>
+                </a:solidFill>
+                <a:latin typeface="Aptos"/>
+              </a:rPr>
+              <a:t>• Prototype status: deployed; 34 unit and 8 end-to-end tests pass. No OCR or login yet.</a:t>
+            </a:r>
+          </a:p>
+          <a:p>
+            <a:pPr algn="l"/>
+            <a:r>
+              <a:rPr sz="1400" b="0">
+                <a:solidFill>
+                  <a:srgbClr val="394252"/>
+                </a:solidFill>
+                <a:latin typeface="Aptos"/>
+              </a:rPr>
+              <a:t/>
+            </a:r>
+          </a:p>
+          <a:p>
+            <a:pPr algn="l"/>
+            <a:r>
+              <a:rPr sz="1400" b="0">
+                <a:solidFill>
+                  <a:srgbClr val="394252"/>
+                </a:solidFill>
+                <a:latin typeface="Aptos"/>
+              </a:rPr>
+              <a:t>• Risk + mitigation: false positives → verified quotes, uncertainty labels, human review.</a:t>
             </a:r>
           </a:p>
         </p:txBody>
@@ -9968,8 +9227,8 @@
         </p:nvSpPr>
         <p:spPr>
           <a:xfrm>
-            <a:off x="6446520" y="2395728"/>
-            <a:ext cx="4892040" cy="2834640"/>
+            <a:off x="6492240" y="2633472"/>
+            <a:ext cx="4663440" cy="2286000"/>
           </a:xfrm>
           <a:prstGeom prst="rect">
             <a:avLst/>
@@ -9982,123 +9241,87 @@
           </a:bodyPr>
           <a:lstStyle/>
           <a:p>
-            <a:pPr algn="l" marL="228600" indent="-228600">
-              <a:spcAft>
-                <a:spcPts val="900"/>
-              </a:spcAft>
-              <a:buClr>
-                <a:srgbClr val="2DA6A0"/>
-              </a:buClr>
-              <a:buFont typeface="Arial"/>
-              <a:buChar char="•"/>
-            </a:pPr>
-            <a:r>
-              <a:rPr sz="1350" b="1">
-                <a:solidFill>
-                  <a:srgbClr val="162239"/>
-                </a:solidFill>
-                <a:latin typeface="Aptos"/>
-              </a:rPr>
-              <a:t>Users &amp; value: </a:t>
-            </a:r>
-            <a:r>
-              <a:rPr sz="1350" b="0">
+            <a:pPr algn="l"/>
+            <a:r>
+              <a:rPr sz="1400" b="0">
                 <a:solidFill>
                   <a:srgbClr val="394252"/>
                 </a:solidFill>
                 <a:latin typeface="Aptos"/>
               </a:rPr>
-              <a:t>authorized reviewers who reconcile records and need evidence, not just alerts.</a:t>
-            </a:r>
-          </a:p>
-          <a:p>
-            <a:pPr algn="l" marL="228600" indent="-228600">
-              <a:spcAft>
-                <a:spcPts val="900"/>
-              </a:spcAft>
-              <a:buClr>
-                <a:srgbClr val="2DA6A0"/>
-              </a:buClr>
-              <a:buFont typeface="Arial"/>
-              <a:buChar char="•"/>
-            </a:pPr>
-            <a:r>
-              <a:rPr sz="1350" b="1">
-                <a:solidFill>
-                  <a:srgbClr val="162239"/>
-                </a:solidFill>
-                <a:latin typeface="Aptos"/>
-              </a:rPr>
-              <a:t>Adoption path: </a:t>
-            </a:r>
-            <a:r>
-              <a:rPr sz="1350" b="0">
+              <a:t>• Target users and value: authorized reviewers who need evidence, not just alerts.</a:t>
+            </a:r>
+          </a:p>
+          <a:p>
+            <a:pPr algn="l"/>
+            <a:r>
+              <a:rPr sz="1400" b="0">
                 <a:solidFill>
                   <a:srgbClr val="394252"/>
                 </a:solidFill>
                 <a:latin typeface="Aptos"/>
               </a:rPr>
-              <a:t>synthetic prototype → representative test set → clinical reviewer feedback → security &amp; privacy review → approved limited pilot.</a:t>
-            </a:r>
-          </a:p>
-          <a:p>
-            <a:pPr algn="l" marL="228600" indent="-228600">
-              <a:spcAft>
-                <a:spcPts val="900"/>
-              </a:spcAft>
-              <a:buClr>
-                <a:srgbClr val="2DA6A0"/>
-              </a:buClr>
-              <a:buFont typeface="Arial"/>
-              <a:buChar char="•"/>
-            </a:pPr>
-            <a:r>
-              <a:rPr sz="1350" b="1">
-                <a:solidFill>
-                  <a:srgbClr val="162239"/>
-                </a:solidFill>
-                <a:latin typeface="Aptos"/>
-              </a:rPr>
-              <a:t>Cost drivers: </a:t>
-            </a:r>
-            <a:r>
-              <a:rPr sz="1350" b="0">
+              <a:t/>
+            </a:r>
+          </a:p>
+          <a:p>
+            <a:pPr algn="l"/>
+            <a:r>
+              <a:rPr sz="1400" b="0">
                 <a:solidFill>
                   <a:srgbClr val="394252"/>
                 </a:solidFill>
                 <a:latin typeface="Aptos"/>
               </a:rPr>
-              <a:t>hosting (static today), document processing, future storage or AI APIs, testing and maintenance.</a:t>
-            </a:r>
-          </a:p>
-          <a:p>
-            <a:pPr algn="l" marL="228600" indent="-228600">
-              <a:spcAft>
-                <a:spcPts val="900"/>
-              </a:spcAft>
-              <a:buClr>
-                <a:srgbClr val="2DA6A0"/>
-              </a:buClr>
-              <a:buFont typeface="Arial"/>
-              <a:buChar char="•"/>
-            </a:pPr>
-            <a:r>
-              <a:rPr sz="1350" b="1">
-                <a:solidFill>
-                  <a:srgbClr val="162239"/>
-                </a:solidFill>
-                <a:latin typeface="Aptos"/>
-              </a:rPr>
-              <a:t>Possible model (future): </a:t>
-            </a:r>
-            <a:r>
-              <a:rPr sz="1350" b="0">
+              <a:t>• Adoption plan: synthetic prototype → test set → clinician feedback → approved pilot.</a:t>
+            </a:r>
+          </a:p>
+          <a:p>
+            <a:pPr algn="l"/>
+            <a:r>
+              <a:rPr sz="1400" b="0">
                 <a:solidFill>
                   <a:srgbClr val="394252"/>
                 </a:solidFill>
                 <a:latin typeface="Aptos"/>
               </a:rPr>
-              <a:t>institutional licensing or record-system integration via pilot partners. No partners or customers today.</a:t>
+              <a:t/>
+            </a:r>
+          </a:p>
+          <a:p>
+            <a:pPr algn="l"/>
+            <a:r>
+              <a:rPr sz="1400" b="0">
+                <a:solidFill>
+                  <a:srgbClr val="394252"/>
+                </a:solidFill>
+                <a:latin typeface="Aptos"/>
+              </a:rPr>
+              <a:t>• Cost and maintenance: hosting, processing, future storage or AI APIs, testing.</a:t>
+            </a:r>
+          </a:p>
+          <a:p>
+            <a:pPr algn="l"/>
+            <a:r>
+              <a:rPr sz="1400" b="0">
+                <a:solidFill>
+                  <a:srgbClr val="394252"/>
+                </a:solidFill>
+                <a:latin typeface="Aptos"/>
+              </a:rPr>
+              <a:t/>
+            </a:r>
+          </a:p>
+          <a:p>
+            <a:pPr algn="l"/>
+            <a:r>
+              <a:rPr sz="1400" b="0">
+                <a:solidFill>
+                  <a:srgbClr val="394252"/>
+                </a:solidFill>
+                <a:latin typeface="Aptos"/>
+              </a:rPr>
+              <a:t>• Revenue (future only): institutional licensing or integration. No partners today.</a:t>
             </a:r>
           </a:p>
         </p:txBody>
@@ -10111,8 +9334,8 @@
         </p:nvSpPr>
         <p:spPr>
           <a:xfrm>
-            <a:off x="868680" y="5486400"/>
-            <a:ext cx="10424160" cy="777240"/>
+            <a:off x="868680" y="5532120"/>
+            <a:ext cx="10424160" cy="502920"/>
           </a:xfrm>
           <a:prstGeom prst="roundRect">
             <a:avLst>
@@ -10158,8 +9381,8 @@
         </p:nvSpPr>
         <p:spPr>
           <a:xfrm>
-            <a:off x="1051560" y="5559552"/>
-            <a:ext cx="10058400" cy="640080"/>
+            <a:off x="1051560" y="5641848"/>
+            <a:ext cx="10058400" cy="228600"/>
           </a:xfrm>
           <a:prstGeom prst="rect">
             <a:avLst/>
@@ -10176,20 +9399,11 @@
             <a:r>
               <a:rPr sz="1300" b="1">
                 <a:solidFill>
-                  <a:srgbClr val="5369DC"/>
-                </a:solidFill>
-                <a:latin typeface="Aptos"/>
-              </a:rPr>
-              <a:t>KEY TAKEAWAY:  </a:t>
-            </a:r>
-            <a:r>
-              <a:rPr sz="1300" b="0">
-                <a:solidFill>
                   <a:srgbClr val="162239"/>
                 </a:solidFill>
                 <a:latin typeface="Aptos"/>
               </a:rPr>
-              <a:t>CLINISCOPE builds on a working software prototype and offers a practical path toward evaluated, evidence-based record review, subject to further validation and secure deployment.</a:t>
+              <a:t>KEY TAKEAWAY:  A working prototype with a practical, validation-first path to evidence-based review.</a:t>
             </a:r>
           </a:p>
         </p:txBody>
@@ -10237,8 +9451,8 @@
         </p:nvSpPr>
         <p:spPr>
           <a:xfrm>
-            <a:off x="10744200" y="6473952"/>
-            <a:ext cx="822960" cy="201168"/>
+            <a:off x="11064240" y="6473952"/>
+            <a:ext cx="502920" cy="201168"/>
           </a:xfrm>
           <a:prstGeom prst="rect">
             <a:avLst/>
@@ -10390,7 +9604,7 @@
                 </a:solidFill>
                 <a:latin typeface="Aptos"/>
               </a:rPr>
-              <a:t>Scalability items and roadmap stages 02–04 are planned, not built; impact is a goal to be measured in evaluation.</a:t>
+              <a:t>Scalability items are planned, not built. Impact is a goal to be measured in evaluation.</a:t>
             </a:r>
           </a:p>
         </p:txBody>
@@ -10538,8 +9752,8 @@
         </p:nvSpPr>
         <p:spPr>
           <a:xfrm>
-            <a:off x="640080" y="1691640"/>
-            <a:ext cx="3474720" cy="2148840"/>
+            <a:off x="640080" y="1874519"/>
+            <a:ext cx="3474720" cy="1828800"/>
           </a:xfrm>
           <a:prstGeom prst="roundRect">
             <a:avLst>
@@ -10585,8 +9799,8 @@
         </p:nvSpPr>
         <p:spPr>
           <a:xfrm>
-            <a:off x="640080" y="1691640"/>
-            <a:ext cx="64008" cy="2148840"/>
+            <a:off x="640080" y="1874519"/>
+            <a:ext cx="64008" cy="1828800"/>
           </a:xfrm>
           <a:prstGeom prst="rect">
             <a:avLst/>
@@ -10630,7 +9844,7 @@
         </p:nvSpPr>
         <p:spPr>
           <a:xfrm>
-            <a:off x="859536" y="1856232"/>
+            <a:off x="859536" y="2057400"/>
             <a:ext cx="3063239" cy="320040"/>
           </a:xfrm>
           <a:prstGeom prst="rect">
@@ -10665,8 +9879,8 @@
         </p:nvSpPr>
         <p:spPr>
           <a:xfrm>
-            <a:off x="859536" y="2240280"/>
-            <a:ext cx="3063239" cy="1463040"/>
+            <a:off x="859536" y="2496312"/>
+            <a:ext cx="3063239" cy="1078992"/>
           </a:xfrm>
           <a:prstGeom prst="rect">
             <a:avLst/>
@@ -10679,108 +9893,15 @@
           </a:bodyPr>
           <a:lstStyle/>
           <a:p>
-            <a:pPr algn="l" marL="228600" indent="-228600">
-              <a:spcAft>
-                <a:spcPts val="100"/>
-              </a:spcAft>
-              <a:buClr>
-                <a:srgbClr val="2DA6A0"/>
-              </a:buClr>
-              <a:buFont typeface="Arial"/>
-              <a:buChar char="•"/>
-            </a:pPr>
-            <a:r>
-              <a:rPr sz="1200" b="0">
+            <a:pPr algn="l"/>
+            <a:r>
+              <a:rPr sz="1300" b="0">
                 <a:solidFill>
                   <a:srgbClr val="394252"/>
                 </a:solidFill>
                 <a:latin typeface="Aptos"/>
               </a:rPr>
-              <a:t>Modular engine in src/lib</a:t>
-            </a:r>
-          </a:p>
-          <a:p>
-            <a:pPr algn="l" marL="228600" indent="-228600">
-              <a:spcAft>
-                <a:spcPts val="100"/>
-              </a:spcAft>
-              <a:buClr>
-                <a:srgbClr val="2DA6A0"/>
-              </a:buClr>
-              <a:buFont typeface="Arial"/>
-              <a:buChar char="•"/>
-            </a:pPr>
-            <a:r>
-              <a:rPr sz="1200" b="0">
-                <a:solidFill>
-                  <a:srgbClr val="394252"/>
-                </a:solidFill>
-                <a:latin typeface="Aptos"/>
-              </a:rPr>
-              <a:t>Regression tests run in CI</a:t>
-            </a:r>
-          </a:p>
-          <a:p>
-            <a:pPr algn="l" marL="228600" indent="-228600">
-              <a:spcAft>
-                <a:spcPts val="100"/>
-              </a:spcAft>
-              <a:buClr>
-                <a:srgbClr val="2DA6A0"/>
-              </a:buClr>
-              <a:buFont typeface="Arial"/>
-              <a:buChar char="•"/>
-            </a:pPr>
-            <a:r>
-              <a:rPr sz="1200" b="0">
-                <a:solidFill>
-                  <a:srgbClr val="394252"/>
-                </a:solidFill>
-                <a:latin typeface="Aptos"/>
-              </a:rPr>
-              <a:t>Versioned DB schema</a:t>
-            </a:r>
-          </a:p>
-          <a:p>
-            <a:pPr algn="l" marL="228600" indent="-228600">
-              <a:spcAft>
-                <a:spcPts val="100"/>
-              </a:spcAft>
-              <a:buClr>
-                <a:srgbClr val="2DA6A0"/>
-              </a:buClr>
-              <a:buFont typeface="Arial"/>
-              <a:buChar char="•"/>
-            </a:pPr>
-            <a:r>
-              <a:rPr sz="1200" b="0">
-                <a:solidFill>
-                  <a:srgbClr val="394252"/>
-                </a:solidFill>
-                <a:latin typeface="Aptos"/>
-              </a:rPr>
-              <a:t>Unsupported files flagged openly</a:t>
-            </a:r>
-          </a:p>
-          <a:p>
-            <a:pPr algn="l" marL="228600" indent="-228600">
-              <a:spcAft>
-                <a:spcPts val="100"/>
-              </a:spcAft>
-              <a:buClr>
-                <a:srgbClr val="2DA6A0"/>
-              </a:buClr>
-              <a:buFont typeface="Arial"/>
-              <a:buChar char="•"/>
-            </a:pPr>
-            <a:r>
-              <a:rPr sz="1200" b="0">
-                <a:solidFill>
-                  <a:srgbClr val="394252"/>
-                </a:solidFill>
-                <a:latin typeface="Aptos"/>
-              </a:rPr>
-              <a:t>Synthetic, governed test data</a:t>
+              <a:t>Modular engine, regression tests in CI, versioned schema, and unsupported files flagged openly rather than guessed.</a:t>
             </a:r>
           </a:p>
         </p:txBody>
@@ -10793,8 +9914,8 @@
         </p:nvSpPr>
         <p:spPr>
           <a:xfrm>
-            <a:off x="4343400" y="1691640"/>
-            <a:ext cx="3474720" cy="2148840"/>
+            <a:off x="4343400" y="1874519"/>
+            <a:ext cx="3474720" cy="1828800"/>
           </a:xfrm>
           <a:prstGeom prst="roundRect">
             <a:avLst>
@@ -10840,8 +9961,8 @@
         </p:nvSpPr>
         <p:spPr>
           <a:xfrm>
-            <a:off x="4343400" y="1691640"/>
-            <a:ext cx="64008" cy="2148840"/>
+            <a:off x="4343400" y="1874519"/>
+            <a:ext cx="64008" cy="1828800"/>
           </a:xfrm>
           <a:prstGeom prst="rect">
             <a:avLst/>
@@ -10885,7 +10006,7 @@
         </p:nvSpPr>
         <p:spPr>
           <a:xfrm>
-            <a:off x="4562856" y="1856232"/>
+            <a:off x="4562856" y="2057400"/>
             <a:ext cx="3063239" cy="320040"/>
           </a:xfrm>
           <a:prstGeom prst="rect">
@@ -10907,16 +10028,7 @@
                 </a:solidFill>
                 <a:latin typeface="Aptos"/>
               </a:rPr>
-              <a:t>SCALABILITY </a:t>
-            </a:r>
-            <a:r>
-              <a:rPr sz="1200" b="0">
-                <a:solidFill>
-                  <a:srgbClr val="767F90"/>
-                </a:solidFill>
-                <a:latin typeface="Aptos"/>
-              </a:rPr>
-              <a:t>(PLANNED)</a:t>
+              <a:t>SCALABILITY</a:t>
             </a:r>
           </a:p>
         </p:txBody>
@@ -10929,8 +10041,8 @@
         </p:nvSpPr>
         <p:spPr>
           <a:xfrm>
-            <a:off x="4562856" y="2240280"/>
-            <a:ext cx="3063239" cy="1463040"/>
+            <a:off x="4562856" y="2496312"/>
+            <a:ext cx="3063239" cy="1078992"/>
           </a:xfrm>
           <a:prstGeom prst="rect">
             <a:avLst/>
@@ -10943,108 +10055,15 @@
           </a:bodyPr>
           <a:lstStyle/>
           <a:p>
-            <a:pPr algn="l" marL="228600" indent="-228600">
-              <a:spcAft>
-                <a:spcPts val="100"/>
-              </a:spcAft>
-              <a:buClr>
-                <a:srgbClr val="2DA6A0"/>
-              </a:buClr>
-              <a:buFont typeface="Arial"/>
-              <a:buChar char="•"/>
-            </a:pPr>
-            <a:r>
-              <a:rPr sz="1200" b="0">
+            <a:pPr algn="l"/>
+            <a:r>
+              <a:rPr sz="1300" b="0">
                 <a:solidFill>
                   <a:srgbClr val="394252"/>
                 </a:solidFill>
                 <a:latin typeface="Aptos"/>
               </a:rPr>
-              <a:t>OCR for scanned records</a:t>
-            </a:r>
-          </a:p>
-          <a:p>
-            <a:pPr algn="l" marL="228600" indent="-228600">
-              <a:spcAft>
-                <a:spcPts val="100"/>
-              </a:spcAft>
-              <a:buClr>
-                <a:srgbClr val="2DA6A0"/>
-              </a:buClr>
-              <a:buFont typeface="Arial"/>
-              <a:buChar char="•"/>
-            </a:pPr>
-            <a:r>
-              <a:rPr sz="1200" b="0">
-                <a:solidFill>
-                  <a:srgbClr val="394252"/>
-                </a:solidFill>
-                <a:latin typeface="Aptos"/>
-              </a:rPr>
-              <a:t>More formats and vocabulary</a:t>
-            </a:r>
-          </a:p>
-          <a:p>
-            <a:pPr algn="l" marL="228600" indent="-228600">
-              <a:spcAft>
-                <a:spcPts val="100"/>
-              </a:spcAft>
-              <a:buClr>
-                <a:srgbClr val="2DA6A0"/>
-              </a:buClr>
-              <a:buFont typeface="Arial"/>
-              <a:buChar char="•"/>
-            </a:pPr>
-            <a:r>
-              <a:rPr sz="1200" b="0">
-                <a:solidFill>
-                  <a:srgbClr val="394252"/>
-                </a:solidFill>
-                <a:latin typeface="Aptos"/>
-              </a:rPr>
-              <a:t>Evidence-checked AI assistance</a:t>
-            </a:r>
-          </a:p>
-          <a:p>
-            <a:pPr algn="l" marL="228600" indent="-228600">
-              <a:spcAft>
-                <a:spcPts val="100"/>
-              </a:spcAft>
-              <a:buClr>
-                <a:srgbClr val="2DA6A0"/>
-              </a:buClr>
-              <a:buFont typeface="Arial"/>
-              <a:buChar char="•"/>
-            </a:pPr>
-            <a:r>
-              <a:rPr sz="1200" b="0">
-                <a:solidFill>
-                  <a:srgbClr val="394252"/>
-                </a:solidFill>
-                <a:latin typeface="Aptos"/>
-              </a:rPr>
-              <a:t>Secure backend, login, multi-user</a:t>
-            </a:r>
-          </a:p>
-          <a:p>
-            <a:pPr algn="l" marL="228600" indent="-228600">
-              <a:spcAft>
-                <a:spcPts val="100"/>
-              </a:spcAft>
-              <a:buClr>
-                <a:srgbClr val="2DA6A0"/>
-              </a:buClr>
-              <a:buFont typeface="Arial"/>
-              <a:buChar char="•"/>
-            </a:pPr>
-            <a:r>
-              <a:rPr sz="1200" b="0">
-                <a:solidFill>
-                  <a:srgbClr val="394252"/>
-                </a:solidFill>
-                <a:latin typeface="Aptos"/>
-              </a:rPr>
-              <a:t>Record-system integration</a:t>
+              <a:t>Planned: OCR for scans, more formats, evidence-checked AI help, secure backend with login and multi-user review.</a:t>
             </a:r>
           </a:p>
         </p:txBody>
@@ -11057,8 +10076,8 @@
         </p:nvSpPr>
         <p:spPr>
           <a:xfrm>
-            <a:off x="8046720" y="1691640"/>
-            <a:ext cx="3474720" cy="2148840"/>
+            <a:off x="8046720" y="1874519"/>
+            <a:ext cx="3474720" cy="1828800"/>
           </a:xfrm>
           <a:prstGeom prst="roundRect">
             <a:avLst>
@@ -11104,8 +10123,8 @@
         </p:nvSpPr>
         <p:spPr>
           <a:xfrm>
-            <a:off x="8046720" y="1691640"/>
-            <a:ext cx="64008" cy="2148840"/>
+            <a:off x="8046720" y="1874519"/>
+            <a:ext cx="64008" cy="1828800"/>
           </a:xfrm>
           <a:prstGeom prst="rect">
             <a:avLst/>
@@ -11149,7 +10168,7 @@
         </p:nvSpPr>
         <p:spPr>
           <a:xfrm>
-            <a:off x="8266176" y="1856232"/>
+            <a:off x="8266176" y="2057400"/>
             <a:ext cx="3063239" cy="320040"/>
           </a:xfrm>
           <a:prstGeom prst="rect">
@@ -11171,16 +10190,7 @@
                 </a:solidFill>
                 <a:latin typeface="Aptos"/>
               </a:rPr>
-              <a:t>EXPECTED IMPACT </a:t>
-            </a:r>
-            <a:r>
-              <a:rPr sz="1200" b="0">
-                <a:solidFill>
-                  <a:srgbClr val="767F90"/>
-                </a:solidFill>
-                <a:latin typeface="Aptos"/>
-              </a:rPr>
-              <a:t>(GOALS)</a:t>
+              <a:t>EXPECTED IMPACT</a:t>
             </a:r>
           </a:p>
         </p:txBody>
@@ -11193,8 +10203,8 @@
         </p:nvSpPr>
         <p:spPr>
           <a:xfrm>
-            <a:off x="8266176" y="2240280"/>
-            <a:ext cx="3063239" cy="1463040"/>
+            <a:off x="8266176" y="2496312"/>
+            <a:ext cx="3063239" cy="1078992"/>
           </a:xfrm>
           <a:prstGeom prst="rect">
             <a:avLst/>
@@ -11207,108 +10217,15 @@
           </a:bodyPr>
           <a:lstStyle/>
           <a:p>
-            <a:pPr algn="l" marL="228600" indent="-228600">
-              <a:spcAft>
-                <a:spcPts val="100"/>
-              </a:spcAft>
-              <a:buClr>
-                <a:srgbClr val="2DA6A0"/>
-              </a:buClr>
-              <a:buFont typeface="Arial"/>
-              <a:buChar char="•"/>
-            </a:pPr>
-            <a:r>
-              <a:rPr sz="1200" b="0">
+            <a:pPr algn="l"/>
+            <a:r>
+              <a:rPr sz="1300" b="0">
                 <a:solidFill>
                   <a:srgbClr val="394252"/>
                 </a:solidFill>
                 <a:latin typeface="Aptos"/>
               </a:rPr>
-              <a:t>Aims to cut manual searching</a:t>
-            </a:r>
-          </a:p>
-          <a:p>
-            <a:pPr algn="l" marL="228600" indent="-228600">
-              <a:spcAft>
-                <a:spcPts val="100"/>
-              </a:spcAft>
-              <a:buClr>
-                <a:srgbClr val="2DA6A0"/>
-              </a:buClr>
-              <a:buFont typeface="Arial"/>
-              <a:buChar char="•"/>
-            </a:pPr>
-            <a:r>
-              <a:rPr sz="1200" b="0">
-                <a:solidFill>
-                  <a:srgbClr val="394252"/>
-                </a:solidFill>
-                <a:latin typeface="Aptos"/>
-              </a:rPr>
-              <a:t>More traceable investigations</a:t>
-            </a:r>
-          </a:p>
-          <a:p>
-            <a:pPr algn="l" marL="228600" indent="-228600">
-              <a:spcAft>
-                <a:spcPts val="100"/>
-              </a:spcAft>
-              <a:buClr>
-                <a:srgbClr val="2DA6A0"/>
-              </a:buClr>
-              <a:buFont typeface="Arial"/>
-              <a:buChar char="•"/>
-            </a:pPr>
-            <a:r>
-              <a:rPr sz="1200" b="0">
-                <a:solidFill>
-                  <a:srgbClr val="394252"/>
-                </a:solidFill>
-                <a:latin typeface="Aptos"/>
-              </a:rPr>
-              <a:t>Clearer view of source evidence</a:t>
-            </a:r>
-          </a:p>
-          <a:p>
-            <a:pPr algn="l" marL="228600" indent="-228600">
-              <a:spcAft>
-                <a:spcPts val="100"/>
-              </a:spcAft>
-              <a:buClr>
-                <a:srgbClr val="2DA6A0"/>
-              </a:buClr>
-              <a:buFont typeface="Arial"/>
-              <a:buChar char="•"/>
-            </a:pPr>
-            <a:r>
-              <a:rPr sz="1200" b="0">
-                <a:solidFill>
-                  <a:srgbClr val="394252"/>
-                </a:solidFill>
-                <a:latin typeface="Aptos"/>
-              </a:rPr>
-              <a:t>Structured review records</a:t>
-            </a:r>
-          </a:p>
-          <a:p>
-            <a:pPr algn="l" marL="228600" indent="-228600">
-              <a:spcAft>
-                <a:spcPts val="100"/>
-              </a:spcAft>
-              <a:buClr>
-                <a:srgbClr val="2DA6A0"/>
-              </a:buClr>
-              <a:buFont typeface="Arial"/>
-              <a:buChar char="•"/>
-            </a:pPr>
-            <a:r>
-              <a:rPr sz="1200" b="0">
-                <a:solidFill>
-                  <a:srgbClr val="394252"/>
-                </a:solidFill>
-                <a:latin typeface="Aptos"/>
-              </a:rPr>
-              <a:t>Better awareness of uncertainty</a:t>
+              <a:t>Aims to reduce manual searching, make investigations traceable and record review decisions consistently.</a:t>
             </a:r>
           </a:p>
         </p:txBody>
@@ -11321,7 +10238,7 @@
         </p:nvSpPr>
         <p:spPr>
           <a:xfrm>
-            <a:off x="731520" y="3977639"/>
+            <a:off x="731520" y="4069080"/>
             <a:ext cx="10698480" cy="320040"/>
           </a:xfrm>
           <a:prstGeom prst="rect">
@@ -11356,8 +10273,8 @@
         </p:nvSpPr>
         <p:spPr>
           <a:xfrm>
-            <a:off x="914400" y="4572000"/>
-            <a:ext cx="8961120" cy="45720"/>
+            <a:off x="914400" y="4773168"/>
+            <a:ext cx="9966960" cy="45720"/>
           </a:xfrm>
           <a:prstGeom prst="rect">
             <a:avLst/>
@@ -11401,7 +10318,7 @@
         </p:nvSpPr>
         <p:spPr>
           <a:xfrm>
-            <a:off x="960120" y="4398264"/>
+            <a:off x="960120" y="4590288"/>
             <a:ext cx="384048" cy="384048"/>
           </a:xfrm>
           <a:prstGeom prst="ellipse">
@@ -11446,8 +10363,8 @@
         </p:nvSpPr>
         <p:spPr>
           <a:xfrm>
-            <a:off x="914400" y="4873752"/>
-            <a:ext cx="2423160" cy="594360"/>
+            <a:off x="914400" y="5102352"/>
+            <a:ext cx="1600200" cy="228600"/>
           </a:xfrm>
           <a:prstGeom prst="rect">
             <a:avLst/>
@@ -11468,19 +10385,7 @@
                 </a:solidFill>
                 <a:latin typeface="Aptos"/>
               </a:rPr>
-              <a:t>01  Prototype (now)</a:t>
-            </a:r>
-          </a:p>
-          <a:p>
-            <a:pPr algn="l"/>
-            <a:r>
-              <a:rPr sz="1050" b="0">
-                <a:solidFill>
-                  <a:srgbClr val="394252"/>
-                </a:solidFill>
-                <a:latin typeface="Aptos"/>
-              </a:rPr>
-              <a:t>Synthetic records: ingestion, evidence, review</a:t>
+              <a:t>01  Prototype</a:t>
             </a:r>
           </a:p>
         </p:txBody>
@@ -11493,7 +10398,7 @@
         </p:nvSpPr>
         <p:spPr>
           <a:xfrm>
-            <a:off x="3566160" y="4398264"/>
+            <a:off x="3429000" y="4590288"/>
             <a:ext cx="384048" cy="384048"/>
           </a:xfrm>
           <a:prstGeom prst="ellipse">
@@ -11538,8 +10443,8 @@
         </p:nvSpPr>
         <p:spPr>
           <a:xfrm>
-            <a:off x="3520440" y="4873752"/>
-            <a:ext cx="2423160" cy="594360"/>
+            <a:off x="3383280" y="5102352"/>
+            <a:ext cx="1600200" cy="228600"/>
           </a:xfrm>
           <a:prstGeom prst="rect">
             <a:avLst/>
@@ -11563,18 +10468,6 @@
               <a:t>02  Pilot testing</a:t>
             </a:r>
           </a:p>
-          <a:p>
-            <a:pPr algn="l"/>
-            <a:r>
-              <a:rPr sz="1050" b="0">
-                <a:solidFill>
-                  <a:srgbClr val="394252"/>
-                </a:solidFill>
-                <a:latin typeface="Aptos"/>
-              </a:rPr>
-              <a:t>Measure extraction, accuracy and usability</a:t>
-            </a:r>
-          </a:p>
         </p:txBody>
       </p:sp>
       <p:sp>
@@ -11585,7 +10478,7 @@
         </p:nvSpPr>
         <p:spPr>
           <a:xfrm>
-            <a:off x="6172200" y="4398264"/>
+            <a:off x="5897880" y="4590288"/>
             <a:ext cx="384048" cy="384048"/>
           </a:xfrm>
           <a:prstGeom prst="ellipse">
@@ -11630,8 +10523,8 @@
         </p:nvSpPr>
         <p:spPr>
           <a:xfrm>
-            <a:off x="6126480" y="4873752"/>
-            <a:ext cx="2423160" cy="594360"/>
+            <a:off x="5852160" y="5102352"/>
+            <a:ext cx="1600200" cy="228600"/>
           </a:xfrm>
           <a:prstGeom prst="rect">
             <a:avLst/>
@@ -11655,18 +10548,6 @@
               <a:t>03  Improve</a:t>
             </a:r>
           </a:p>
-          <a:p>
-            <a:pPr algn="l"/>
-            <a:r>
-              <a:rPr sz="1050" b="0">
-                <a:solidFill>
-                  <a:srgbClr val="394252"/>
-                </a:solidFill>
-                <a:latin typeface="Aptos"/>
-              </a:rPr>
-              <a:t>OCR, context, evidence checks, security</a:t>
-            </a:r>
-          </a:p>
         </p:txBody>
       </p:sp>
       <p:sp>
@@ -11677,7 +10558,7 @@
         </p:nvSpPr>
         <p:spPr>
           <a:xfrm>
-            <a:off x="8778240" y="4398264"/>
+            <a:off x="8366760" y="4590288"/>
             <a:ext cx="384048" cy="384048"/>
           </a:xfrm>
           <a:prstGeom prst="ellipse">
@@ -11722,8 +10603,8 @@
         </p:nvSpPr>
         <p:spPr>
           <a:xfrm>
-            <a:off x="8732520" y="4873752"/>
-            <a:ext cx="2423160" cy="594360"/>
+            <a:off x="8321040" y="5102352"/>
+            <a:ext cx="1600200" cy="228600"/>
           </a:xfrm>
           <a:prstGeom prst="rect">
             <a:avLst/>
@@ -11747,18 +10628,6 @@
               <a:t>04  Deploy &amp; scale</a:t>
             </a:r>
           </a:p>
-          <a:p>
-            <a:pPr algn="l"/>
-            <a:r>
-              <a:rPr sz="1050" b="0">
-                <a:solidFill>
-                  <a:srgbClr val="394252"/>
-                </a:solidFill>
-                <a:latin typeface="Aptos"/>
-              </a:rPr>
-              <a:t>Only after accuracy, privacy and approvals</a:t>
-            </a:r>
-          </a:p>
         </p:txBody>
       </p:sp>
       <p:sp>
@@ -11769,8 +10638,8 @@
         </p:nvSpPr>
         <p:spPr>
           <a:xfrm>
-            <a:off x="777240" y="5577840"/>
-            <a:ext cx="10698480" cy="685800"/>
+            <a:off x="777240" y="5715000"/>
+            <a:ext cx="10698480" cy="320040"/>
           </a:xfrm>
           <a:prstGeom prst="rect">
             <a:avLst/>
@@ -11785,22 +10654,13 @@
           <a:p>
             <a:pPr algn="l"/>
             <a:r>
-              <a:rPr sz="1200" b="1">
-                <a:solidFill>
-                  <a:srgbClr val="5369DC"/>
-                </a:solidFill>
-                <a:latin typeface="Aptos"/>
-              </a:rPr>
-              <a:t>SUCCESS METRICS (to be measured):  </a:t>
-            </a:r>
-            <a:r>
-              <a:rPr sz="1200" b="0">
+              <a:rPr sz="1300" b="1">
                 <a:solidFill>
                   <a:srgbClr val="162239"/>
                 </a:solidFill>
                 <a:latin typeface="Aptos"/>
               </a:rPr>
-              <a:t>detection precision &amp; recall on a labelled set  •  % of findings with verifiable evidence  •  false-positive rate  •  reviewer agreement  •  median time per finding  •  extraction success rate</a:t>
+              <a:t>SUCCESS METRIC:  Precision/recall on labelled records, % findings with evidence, reviewer agreement.</a:t>
             </a:r>
           </a:p>
         </p:txBody>
@@ -11848,8 +10708,8 @@
         </p:nvSpPr>
         <p:spPr>
           <a:xfrm>
-            <a:off x="10744200" y="6473952"/>
-            <a:ext cx="822960" cy="201168"/>
+            <a:off x="11064240" y="6473952"/>
+            <a:ext cx="502920" cy="201168"/>
           </a:xfrm>
           <a:prstGeom prst="rect">
             <a:avLst/>
@@ -12024,8 +10884,8 @@
         </p:nvSpPr>
         <p:spPr>
           <a:xfrm>
-            <a:off x="777240" y="2057400"/>
-            <a:ext cx="7589520" cy="1188720"/>
+            <a:off x="777240" y="2103120"/>
+            <a:ext cx="7223760" cy="960120"/>
           </a:xfrm>
           <a:prstGeom prst="rect">
             <a:avLst/>
@@ -12046,7 +10906,7 @@
                 </a:solidFill>
                 <a:latin typeface="Aptos"/>
               </a:rPr>
-              <a:t>CLINISCOPE helps reviewers identify potential inconsistencies across healthcare documents, trace every finding to verified source evidence, and record decisions with human oversight.</a:t>
+              <a:t>CLINISCOPE helps reviewers find potential conflicts across healthcare records, trace each one to source evidence, and record decisions with human oversight.</a:t>
             </a:r>
           </a:p>
         </p:txBody>
@@ -12105,7 +10965,7 @@
         <p:spPr>
           <a:xfrm>
             <a:off x="777240" y="3794760"/>
-            <a:ext cx="7589520" cy="594360"/>
+            <a:ext cx="7132320" cy="594360"/>
           </a:xfrm>
           <a:prstGeom prst="rect">
             <a:avLst/>
@@ -12120,7 +10980,7 @@
           <a:p>
             <a:pPr algn="l"/>
             <a:r>
-              <a:rPr sz="1800" b="1">
+              <a:rPr sz="1600" b="1">
                 <a:solidFill>
                   <a:srgbClr val="FFFFFF"/>
                 </a:solidFill>
@@ -12139,7 +10999,7 @@
         </p:nvSpPr>
         <p:spPr>
           <a:xfrm>
-            <a:off x="777240" y="4526280"/>
+            <a:off x="777240" y="4983480"/>
             <a:ext cx="6858000" cy="502920"/>
           </a:xfrm>
           <a:prstGeom prst="rect">
@@ -12174,8 +11034,8 @@
         </p:nvSpPr>
         <p:spPr>
           <a:xfrm>
-            <a:off x="777240" y="5074920"/>
-            <a:ext cx="7772400" cy="1097280"/>
+            <a:off x="777240" y="5577840"/>
+            <a:ext cx="7132320" cy="411480"/>
           </a:xfrm>
           <a:prstGeom prst="rect">
             <a:avLst/>
@@ -12188,105 +11048,27 @@
           </a:bodyPr>
           <a:lstStyle/>
           <a:p>
-            <a:pPr algn="l">
-              <a:spcAft>
-                <a:spcPts val="300"/>
-              </a:spcAft>
-            </a:pPr>
-            <a:r>
-              <a:rPr sz="1100" b="1">
-                <a:solidFill>
-                  <a:srgbClr val="C0CAFF"/>
-                </a:solidFill>
-                <a:latin typeface="Aptos"/>
-              </a:rPr>
-              <a:t>PS-11R3  </a:t>
-            </a:r>
+            <a:pPr algn="l"/>
             <a:r>
               <a:rPr sz="1100" b="0">
                 <a:solidFill>
-                  <a:srgbClr val="DEE3ED"/>
-                </a:solidFill>
-                <a:latin typeface="Aptos"/>
-              </a:rPr>
-              <a:t>Healthcare Record Contradiction Detector</a:t>
-            </a:r>
-          </a:p>
-          <a:p>
-            <a:pPr algn="l">
-              <a:spcAft>
-                <a:spcPts val="300"/>
-              </a:spcAft>
-            </a:pPr>
-            <a:r>
-              <a:rPr sz="1100" b="1">
-                <a:solidFill>
-                  <a:srgbClr val="C0CAFF"/>
-                </a:solidFill>
-                <a:latin typeface="Aptos"/>
-              </a:rPr>
-              <a:t>Live demo:  </a:t>
-            </a:r>
+                  <a:srgbClr val="D0D7E7"/>
+                </a:solidFill>
+                <a:latin typeface="Aptos"/>
+              </a:rPr>
+              <a:t>[Add team email]  •  github.com/anirudhleetcode-max/cliniscope-healthcare-contradiction-detector</a:t>
+            </a:r>
+          </a:p>
+          <a:p>
+            <a:pPr algn="l"/>
             <a:r>
               <a:rPr sz="1100" b="0">
                 <a:solidFill>
-                  <a:srgbClr val="DEE3ED"/>
-                </a:solidFill>
-                <a:latin typeface="Aptos"/>
-                <a:hlinkClick r:id="rId2"/>
-              </a:rPr>
-              <a:t>anirudhleetcode-max.github.io/cliniscope-healthcare-contradiction-detector</a:t>
-            </a:r>
-          </a:p>
-          <a:p>
-            <a:pPr algn="l">
-              <a:spcAft>
-                <a:spcPts val="300"/>
-              </a:spcAft>
-            </a:pPr>
-            <a:r>
-              <a:rPr sz="1100" b="1">
-                <a:solidFill>
-                  <a:srgbClr val="C0CAFF"/>
-                </a:solidFill>
-                <a:latin typeface="Aptos"/>
-              </a:rPr>
-              <a:t>Code:  </a:t>
-            </a:r>
-            <a:r>
-              <a:rPr sz="1100" b="0">
-                <a:solidFill>
-                  <a:srgbClr val="DEE3ED"/>
-                </a:solidFill>
-                <a:latin typeface="Aptos"/>
-                <a:hlinkClick r:id="rId3"/>
-              </a:rPr>
-              <a:t>github.com/anirudhleetcode-max/cliniscope-healthcare-contradiction-detector</a:t>
-            </a:r>
-          </a:p>
-          <a:p>
-            <a:pPr algn="l">
-              <a:spcAft>
-                <a:spcPts val="300"/>
-              </a:spcAft>
-            </a:pPr>
-            <a:r>
-              <a:rPr sz="1100" b="1">
-                <a:solidFill>
-                  <a:srgbClr val="C0CAFF"/>
-                </a:solidFill>
-                <a:latin typeface="Aptos"/>
-              </a:rPr>
-              <a:t>Contact:  </a:t>
-            </a:r>
-            <a:r>
-              <a:rPr sz="1100" b="0">
-                <a:solidFill>
-                  <a:srgbClr val="A0AECC"/>
-                </a:solidFill>
-                <a:latin typeface="Aptos"/>
-              </a:rPr>
-              <a:t>[Add team email]</a:t>
+                  <a:srgbClr val="D0D7E7"/>
+                </a:solidFill>
+                <a:latin typeface="Aptos"/>
+              </a:rPr>
+              <a:t>Live demo: anirudhleetcode-max.github.io/cliniscope-healthcare-contradiction-detector  (scan QR)</a:t>
             </a:r>
           </a:p>
         </p:txBody>
@@ -12299,7 +11081,7 @@
         </p:nvSpPr>
         <p:spPr>
           <a:xfrm>
-            <a:off x="9464040" y="914400"/>
+            <a:off x="9464040" y="1371600"/>
             <a:ext cx="1600200" cy="1600200"/>
           </a:xfrm>
           <a:prstGeom prst="roundRect">
@@ -12346,7 +11128,7 @@
         </p:nvSpPr>
         <p:spPr>
           <a:xfrm>
-            <a:off x="10195560" y="2743200"/>
+            <a:off x="10195560" y="3246120"/>
             <a:ext cx="1005840" cy="1005840"/>
           </a:xfrm>
           <a:prstGeom prst="roundRect">
@@ -12393,8 +11175,8 @@
         </p:nvSpPr>
         <p:spPr>
           <a:xfrm>
-            <a:off x="9052560" y="6263640"/>
-            <a:ext cx="2926080" cy="274320"/>
+            <a:off x="9144000" y="6126480"/>
+            <a:ext cx="2651760" cy="228600"/>
           </a:xfrm>
           <a:prstGeom prst="rect">
             <a:avLst/>
@@ -12429,14 +11211,14 @@
           <p:nvPr/>
         </p:nvPicPr>
         <p:blipFill>
-          <a:blip r:embed="rId4"/>
+          <a:blip r:embed="rId2"/>
           <a:stretch>
             <a:fillRect/>
           </a:stretch>
         </p:blipFill>
         <p:spPr>
           <a:xfrm>
-            <a:off x="10378440" y="4389120"/>
+            <a:off x="9464040" y="4526280"/>
             <a:ext cx="1371600" cy="1371600"/>
           </a:xfrm>
           <a:prstGeom prst="rect">
@@ -12444,41 +11226,6 @@
           </a:prstGeom>
         </p:spPr>
       </p:pic>
-      <p:sp>
-        <p:nvSpPr>
-          <p:cNvPr id="14" name="QR Caption"/>
-          <p:cNvSpPr txBox="1"/>
-          <p:nvPr/>
-        </p:nvSpPr>
-        <p:spPr>
-          <a:xfrm>
-            <a:off x="9052560" y="5870448"/>
-            <a:ext cx="2926080" cy="228600"/>
-          </a:xfrm>
-          <a:prstGeom prst="rect">
-            <a:avLst/>
-          </a:prstGeom>
-          <a:noFill/>
-        </p:spPr>
-        <p:txBody>
-          <a:bodyPr wrap="square" anchor="t">
-            <a:spAutoFit/>
-          </a:bodyPr>
-          <a:lstStyle/>
-          <a:p>
-            <a:pPr algn="r"/>
-            <a:r>
-              <a:rPr sz="900" b="1">
-                <a:solidFill>
-                  <a:srgbClr val="C0CAFF"/>
-                </a:solidFill>
-                <a:latin typeface="Aptos"/>
-              </a:rPr>
-              <a:t>SCAN FOR LIVE DEMO</a:t>
-            </a:r>
-          </a:p>
-        </p:txBody>
-      </p:sp>
     </p:spTree>
   </p:cSld>
   <p:clrMapOvr>
@@ -12522,10 +11269,10 @@
         <a:srgbClr val="F79646"/>
       </a:accent6>
       <a:hlink>
-        <a:srgbClr val="C0CAFF"/>
+        <a:srgbClr val="0000FF"/>
       </a:hlink>
       <a:folHlink>
-        <a:srgbClr val="A0AECC"/>
+        <a:srgbClr val="800080"/>
       </a:folHlink>
     </a:clrScheme>
     <a:fontScheme name="Office">

</xml_diff>

<commit_message>
docs: update deck for OCR, optional API and AI layer now on the base branch
Merges the base branch (on-device OCR, shared-workspace API, AI-assisted
reasoning) and updates the slide text to state each feature's real status:
OCR live, API tested locally but not hosted, AI pipeline tested only with a
fake provider. Test counts updated to 68 unit and 12 e2e (run locally on the
merged tree). Template geometry and font sizes still unchanged.

Co-Authored-By: Claude Opus 5.5 <noreply@anthropic.com>
Claude-Session: https://claude.ai/code/session_01FwuQgG7UNrQVjMVMPvyfY9
</commit_message>
<xml_diff>
--- a/presentation/CLINISCOPE_PS11R3_Hackathon_Presentation.pptx
+++ b/presentation/CLINISCOPE_PS11R3_Hackathon_Presentation.pptx
@@ -4024,7 +4024,7 @@
                 </a:solidFill>
                 <a:latin typeface="Aptos"/>
               </a:rPr>
-              <a:t>Patient information is spread across many documents. Allergies, doses, diagnoses and lab results can differ, and spotting that by hand is slow.</a:t>
+              <a:t>Patient information is spread across digital and scanned documents. Allergies, doses, diagnoses and lab results can differ, and spotting that by hand is slow.</a:t>
             </a:r>
           </a:p>
         </p:txBody>
@@ -5067,7 +5067,7 @@
                 </a:solidFill>
                 <a:latin typeface="Aptos"/>
               </a:rPr>
-              <a:t>CLINISCOPE extracts text from PDF, TXT and DOCX records, finds allergy, medication, diagnosis and lab statements with rules, compares them across a case and flags potential conflicts with verified source quotes for human review.</a:t>
+              <a:t>CLINISCOPE reads PDF, scanned, image, TXT and DOCX records (OCR for scans), finds clinical statements with rules, compares them across a case and flags potential conflicts with verified source quotes for human review.</a:t>
             </a:r>
           </a:p>
         </p:txBody>
@@ -5229,7 +5229,7 @@
                 </a:solidFill>
                 <a:latin typeface="Aptos"/>
               </a:rPr>
-              <a:t>Every finding is traceable to an exact source quote. Dated or documented changes are separated from true conflicts, and people make the final call.</a:t>
+              <a:t>Every finding links to an exact source quote, with OCR confidence shown. AI suggestions must verify too, and people make the final call.</a:t>
             </a:r>
           </a:p>
         </p:txBody>
@@ -5391,7 +5391,7 @@
                 </a:solidFill>
                 <a:latin typeface="Aptos"/>
               </a:rPr>
-              <a:t>PDF (text layer), TXT and DOCX are validated and extracted in the browser.</a:t>
+              <a:t>PDF, scans (on-device OCR), images, TXT and DOCX, read in the browser.</a:t>
             </a:r>
           </a:p>
         </p:txBody>
@@ -5553,7 +5553,7 @@
                 </a:solidFill>
                 <a:latin typeface="Aptos"/>
               </a:rPr>
-              <a:t>Rule-based comparison flags potential conflicts with source quotes.</a:t>
+              <a:t>Rules flag conflicts with quotes; optional AI ideas are quote-checked.</a:t>
             </a:r>
           </a:p>
         </p:txBody>
@@ -5715,7 +5715,7 @@
                 </a:solidFill>
                 <a:latin typeface="Aptos"/>
               </a:rPr>
-              <a:t>Decisions need a reason; every action is kept in an audit log.</a:t>
+              <a:t>Reasons required, audit log, optional shared cases with roles.</a:t>
             </a:r>
           </a:p>
         </p:txBody>
@@ -5951,7 +5951,7 @@
                 </a:solidFill>
                 <a:latin typeface="Aptos"/>
               </a:rPr>
-              <a:t>Everything runs in the reviewer's browser: no backend server, no AI/LLM and no OCR in the current build.</a:t>
+              <a:t>Browser app with on-device OCR. An optional Node API adds shared cases and AI (not yet publicly hosted).</a:t>
             </a:r>
           </a:p>
         </p:txBody>
@@ -6203,7 +6203,7 @@
                 </a:solidFill>
                 <a:latin typeface="Aptos"/>
               </a:rPr>
-              <a:t>PDF · TXT · DOCX</a:t>
+              <a:t>PDF · scans · DOCX</a:t>
             </a:r>
           </a:p>
         </p:txBody>
@@ -6472,7 +6472,7 @@
                 </a:solidFill>
                 <a:latin typeface="Aptos"/>
               </a:rPr>
-              <a:t>CLIENT SERVICES</a:t>
+              <a:t>OPTIONAL API</a:t>
             </a:r>
           </a:p>
         </p:txBody>
@@ -6507,7 +6507,7 @@
                 </a:solidFill>
                 <a:latin typeface="Aptos"/>
               </a:rPr>
-              <a:t>IndexedDB (Dexie)</a:t>
+              <a:t>Node + SQLite</a:t>
             </a:r>
           </a:p>
         </p:txBody>
@@ -6659,7 +6659,7 @@
                 </a:solidFill>
                 <a:latin typeface="Aptos"/>
               </a:rPr>
-              <a:t>Rule-based engine</a:t>
+              <a:t>OCR · rules · AI</a:t>
             </a:r>
           </a:p>
         </p:txBody>
@@ -6973,7 +6973,7 @@
                 </a:solidFill>
                 <a:latin typeface="Aptos"/>
               </a:rPr>
-              <a:t>Extraction (pdf.js, mammoth) → statement rules → contradiction detection → evidence check → review workflow, stored with Dexie.</a:t>
+              <a:t>OCR (Tesseract.js), pdf.js, mammoth → statement rules → detection → optional AI → quote check → review, stored in IndexedDB or SQLite.</a:t>
             </a:r>
           </a:p>
         </p:txBody>
@@ -7135,7 +7135,7 @@
                 </a:solidFill>
                 <a:latin typeface="Aptos"/>
               </a:rPr>
-              <a:t>Uploads are type- and size-checked. A finding is kept only if its quotes match the source text; dates can reclassify it.</a:t>
+              <a:t>Uploads are type- and size-checked. Any finding, AI included, is kept only if its quotes match the source; low OCR confidence lowers evidence.</a:t>
             </a:r>
           </a:p>
         </p:txBody>
@@ -7170,7 +7170,7 @@
                 </a:solidFill>
                 <a:latin typeface="Aptos"/>
               </a:rPr>
-              <a:t>ARCHITECTURE NOTE:  Extraction, detection and review are separate, unit-tested modules.</a:t>
+              <a:t>ARCHITECTURE NOTE:  Works fully in the browser; the server and AI are optional, separately tested add-ons.</a:t>
             </a:r>
           </a:p>
         </p:txBody>
@@ -7830,7 +7830,7 @@
                 </a:solidFill>
                 <a:latin typeface="Aptos"/>
               </a:rPr>
-              <a:t>None: a browser-side TypeScript service layer runs the workflow.</a:t>
+              <a:t>Optional Node 22 API for accounts, roles and case sharing.</a:t>
             </a:r>
           </a:p>
         </p:txBody>
@@ -7992,7 +7992,7 @@
                 </a:solidFill>
                 <a:latin typeface="Aptos"/>
               </a:rPr>
-              <a:t>IndexedDB via Dexie: cases, files, findings and audit events.</a:t>
+              <a:t>IndexedDB (Dexie) in the browser; SQLite on the server.</a:t>
             </a:r>
           </a:p>
         </p:txBody>
@@ -8154,7 +8154,7 @@
                 </a:solidFill>
                 <a:latin typeface="Aptos"/>
               </a:rPr>
-              <a:t>No AI/LLM: deterministic TypeScript rules for detection.</a:t>
+              <a:t>Deterministic rules; optional Anthropic API, quote-verified.</a:t>
             </a:r>
           </a:p>
         </p:txBody>
@@ -8316,7 +8316,7 @@
                 </a:solidFill>
                 <a:latin typeface="Aptos"/>
               </a:rPr>
-              <a:t>No external APIs. pdfjs-dist (PDF) and mammoth (DOCX) run locally.</a:t>
+              <a:t>Tesseract.js OCR, pdf.js and mammoth run on-device.</a:t>
             </a:r>
           </a:p>
         </p:txBody>
@@ -8478,7 +8478,7 @@
                 </a:solidFill>
                 <a:latin typeface="Aptos"/>
               </a:rPr>
-              <a:t>Git, GitHub Actions (Vitest, Playwright) and GitHub Pages.</a:t>
+              <a:t>GitHub Actions CI, GitHub Pages; Docker/Render for the API.</a:t>
             </a:r>
           </a:p>
         </p:txBody>
@@ -8513,7 +8513,7 @@
                 </a:solidFill>
                 <a:latin typeface="Aptos"/>
               </a:rPr>
-              <a:t>WHY THIS STACK?  A light, testable static web app: records are processed and stored in the browser, so no server is needed. OCR, AI or a backend would be added only when required.</a:t>
+              <a:t>WHY THIS STACK?  The browser app works on its own, so the demo needs no server. The API and AI layer are optional and add sharing and AI only where configured.</a:t>
             </a:r>
           </a:p>
         </p:txBody>
@@ -9142,7 +9142,7 @@
                 </a:solidFill>
                 <a:latin typeface="Aptos"/>
               </a:rPr>
-              <a:t>• Required tools and skills: React, TypeScript, rule design, pdf.js, mammoth, Vitest, Playwright.</a:t>
+              <a:t>• Required tools and skills: React, TypeScript, Node, SQLite, Tesseract.js, Vitest, Playwright.</a:t>
             </a:r>
           </a:p>
           <a:p>
@@ -9166,7 +9166,7 @@
                 </a:solidFill>
                 <a:latin typeface="Aptos"/>
               </a:rPr>
-              <a:t>• Data / infrastructure: synthetic records and browser storage only; no real patient data.</a:t>
+              <a:t>• Data / infrastructure: synthetic records only. Frontend is live; the API is not hosted yet.</a:t>
             </a:r>
           </a:p>
           <a:p>
@@ -9190,7 +9190,7 @@
                 </a:solidFill>
                 <a:latin typeface="Aptos"/>
               </a:rPr>
-              <a:t>• Prototype status: deployed; 34 unit and 8 end-to-end tests pass. No OCR or login yet.</a:t>
+              <a:t>• Prototype status: 68 unit and 12 end-to-end tests pass. AI not yet tried on a live model.</a:t>
             </a:r>
           </a:p>
           <a:p>
@@ -9214,7 +9214,7 @@
                 </a:solidFill>
                 <a:latin typeface="Aptos"/>
               </a:rPr>
-              <a:t>• Risk + mitigation: false positives → verified quotes, uncertainty labels, human review.</a:t>
+              <a:t>• Risk + mitigation: OCR or AI errors → quote checks, confidence labels, human review.</a:t>
             </a:r>
           </a:p>
         </p:txBody>
@@ -9297,7 +9297,7 @@
                 </a:solidFill>
                 <a:latin typeface="Aptos"/>
               </a:rPr>
-              <a:t>• Cost and maintenance: hosting, processing, future storage or AI APIs, testing.</a:t>
+              <a:t>• Cost and maintenance: API hosting, storage, AI usage per analysis, testing.</a:t>
             </a:r>
           </a:p>
           <a:p>
@@ -9604,7 +9604,7 @@
                 </a:solidFill>
                 <a:latin typeface="Aptos"/>
               </a:rPr>
-              <a:t>Scalability items are planned, not built. Impact is a goal to be measured in evaluation.</a:t>
+              <a:t>Scalability items are planned next steps. Impact is a goal to be measured in evaluation.</a:t>
             </a:r>
           </a:p>
         </p:txBody>
@@ -9901,7 +9901,7 @@
                 </a:solidFill>
                 <a:latin typeface="Aptos"/>
               </a:rPr>
-              <a:t>Modular engine, regression tests in CI, versioned schema, and unsupported files flagged openly rather than guessed.</a:t>
+              <a:t>Modular engine, regression tests in CI, versioned migrations, and low-confidence OCR flagged, never guessed.</a:t>
             </a:r>
           </a:p>
         </p:txBody>
@@ -10063,7 +10063,7 @@
                 </a:solidFill>
                 <a:latin typeface="Aptos"/>
               </a:rPr>
-              <a:t>Planned: OCR for scans, more formats, evidence-checked AI help, secure backend with login and multi-user review.</a:t>
+              <a:t>Planned: host the API, test AI on a live model, more formats and vocabulary, record-system integration.</a:t>
             </a:r>
           </a:p>
         </p:txBody>
@@ -10660,7 +10660,7 @@
                 </a:solidFill>
                 <a:latin typeface="Aptos"/>
               </a:rPr>
-              <a:t>SUCCESS METRIC:  Precision/recall on labelled records, % findings with evidence, reviewer agreement.</a:t>
+              <a:t>SUCCESS METRIC:  Precision/recall, OCR error rate on labelled scans, % findings with evidence.</a:t>
             </a:r>
           </a:p>
         </p:txBody>
@@ -10906,7 +10906,7 @@
                 </a:solidFill>
                 <a:latin typeface="Aptos"/>
               </a:rPr>
-              <a:t>CLINISCOPE helps reviewers find potential conflicts across healthcare records, trace each one to source evidence, and record decisions with human oversight.</a:t>
+              <a:t>CLINISCOPE helps reviewers find potential conflicts across digital and scanned healthcare records, trace each one to source evidence, and record decisions with human oversight.</a:t>
             </a:r>
           </a:p>
         </p:txBody>

</xml_diff>